<commit_message>
rewrite presentation: clean sentences, beginner-friendly slides 13+, simplified tech slide
</commit_message>
<xml_diff>
--- a/FitnessHub.pptx
+++ b/FitnessHub.pptx
@@ -518,7 +518,12 @@
           <a:lstStyle/>
           <a:p>
             <a:r>
-              <a:t>Welcome everyone. Today we present Fitness Hub, a Django-based fitness platform built by our team at Shivapuri Secondary School. We'll walk you through the project overview, technical details, and our learning journey.</a:t>
+              <a:rPr>
+                <a:solidFill>
+                  <a:srgbClr val="000000"/>
+                </a:solidFill>
+              </a:rPr>
+              <a:t>Welcome everyone. Today we present Fitness Hub, a Django web application built by Team Codex at Shivapuri Secondary School. The project is live at FitnessHub123.pythonanywhere.com.</a:t>
             </a:r>
           </a:p>
         </p:txBody>
@@ -588,7 +593,12 @@
           <a:lstStyle/>
           <a:p>
             <a:r>
-              <a:t>Authentication uses Django's built-in system with custom Profile creation. The login page shows motivational quotes to inspire users from the start.</a:t>
+              <a:rPr>
+                <a:solidFill>
+                  <a:srgbClr val="000000"/>
+                </a:solidFill>
+              </a:rPr>
+              <a:t>Authentication uses Django's built-in system. Registration creates a Profile automatically. The login page shows motivational quotes.</a:t>
             </a:r>
           </a:p>
         </p:txBody>
@@ -658,7 +668,12 @@
           <a:lstStyle/>
           <a:p>
             <a:r>
-              <a:t>The dashboard is the user's home base. It shows goal readiness, next recommended exercise, weekly stats, recent completions, and motivational feedback based on their progress.</a:t>
+              <a:rPr>
+                <a:solidFill>
+                  <a:srgbClr val="000000"/>
+                </a:solidFill>
+              </a:rPr>
+              <a:t>The dashboard is the user's home base showing goal readiness, weekly stats, recent completions, and motivational feedback.</a:t>
             </a:r>
           </a:p>
         </p:txBody>
@@ -728,7 +743,12 @@
           <a:lstStyle/>
           <a:p>
             <a:r>
-              <a:t>The exercise library has 36 exercises across 7 categories. Each exercise includes detailed instructions, form tips, and safety notes. Users can filter by goal, difficulty, and equipment.</a:t>
+              <a:rPr>
+                <a:solidFill>
+                  <a:srgbClr val="000000"/>
+                </a:solidFill>
+              </a:rPr>
+              <a:t>The exercise library has 36 exercises across 7 categories with detailed instructions, form tips, and safety notes.</a:t>
             </a:r>
           </a:p>
         </p:txBody>
@@ -798,7 +818,12 @@
           <a:lstStyle/>
           <a:p>
             <a:r>
-              <a:t>Users can set 8 different goal types with 6 focus areas. The system automatically assigns relevant exercises based on the selected goal type and tracks progress over time.</a:t>
+              <a:rPr>
+                <a:solidFill>
+                  <a:srgbClr val="000000"/>
+                </a:solidFill>
+              </a:rPr>
+              <a:t>Users can set 8 goal types with 6 focus areas. The system assigns relevant exercises and tracks progress over time.</a:t>
             </a:r>
           </a:p>
         </p:txBody>
@@ -868,7 +893,12 @@
           <a:lstStyle/>
           <a:p>
             <a:r>
-              <a:t>Progress tracking includes exercise history, workout streaks, volume trends over 7 days, body metrics logging, and personalized suggestions based on the user's current goal and performance.</a:t>
+              <a:rPr>
+                <a:solidFill>
+                  <a:srgbClr val="000000"/>
+                </a:solidFill>
+              </a:rPr>
+              <a:t>Progress tracking includes exercise history, streaks, volume trends, body metrics, and personalized goal suggestions.</a:t>
             </a:r>
           </a:p>
         </p:txBody>
@@ -938,7 +968,12 @@
           <a:lstStyle/>
           <a:p>
             <a:r>
-              <a:t>The diet module includes BMR/TDEE calculation, macro tracking, affordable food database with nutritional info, and budget meal presets tailored to the user's fitness goals.</a:t>
+              <a:rPr>
+                <a:solidFill>
+                  <a:srgbClr val="000000"/>
+                </a:solidFill>
+              </a:rPr>
+              <a:t>The diet module includes BMR/TDEE calculation, macro tracking, affordable food database, and budget meal presets.</a:t>
             </a:r>
           </a:p>
         </p:txBody>
@@ -1008,7 +1043,12 @@
           <a:lstStyle/>
           <a:p>
             <a:r>
-              <a:t>The store has 12 products across 3 categories. It includes a full shopping cart, checkout with atomic stock deduction to prevent overselling, and order history tracking.</a:t>
+              <a:rPr>
+                <a:solidFill>
+                  <a:srgbClr val="000000"/>
+                </a:solidFill>
+              </a:rPr>
+              <a:t>The store has 12 products across 3 categories with cart, checkout, atomic stock deduction, and order history.</a:t>
             </a:r>
           </a:p>
         </p:txBody>
@@ -1078,7 +1118,12 @@
           <a:lstStyle/>
           <a:p>
             <a:r>
-              <a:t>The inspiration module features 23 fitness icons with biographies, training tips, and YouTube videos. It includes 88 seeded quotes, category filtering, and a random quote API.</a:t>
+              <a:rPr>
+                <a:solidFill>
+                  <a:srgbClr val="000000"/>
+                </a:solidFill>
+              </a:rPr>
+              <a:t>The inspiration module features 23 fitness icons with 88 quotes. Users can browse by category or get random motivation.</a:t>
             </a:r>
           </a:p>
         </p:txBody>
@@ -1148,7 +1193,12 @@
           <a:lstStyle/>
           <a:p>
             <a:r>
-              <a:t>Social features include partner and rival connections with accept/reject functionality, private messaging between accepted connections, user search, and a social hub showing all activity.</a:t>
+              <a:rPr>
+                <a:solidFill>
+                  <a:srgbClr val="000000"/>
+                </a:solidFill>
+              </a:rPr>
+              <a:t>Social features include connections, private messaging, user search, and a social hub showing all activity.</a:t>
             </a:r>
           </a:p>
         </p:txBody>
@@ -1218,7 +1268,12 @@
           <a:lstStyle/>
           <a:p>
             <a:r>
-              <a:t>The achievements system has 6 categories with unlockable badges. Each achievement has a threshold, and users can track their unlocked badges grouped by category.</a:t>
+              <a:rPr>
+                <a:solidFill>
+                  <a:srgbClr val="000000"/>
+                </a:solidFill>
+              </a:rPr>
+              <a:t>The achievements system has 6 categories with unlockable badges. Each achievement has a threshold to reach.</a:t>
             </a:r>
           </a:p>
         </p:txBody>
@@ -1288,7 +1343,12 @@
           <a:lstStyle/>
           <a:p>
             <a:r>
-              <a:t>Django admin provides full CRUD for all models. The Core app adds SiteSetting for key-value configuration. Admins can manage exercises, users, orders, and inspiration content.</a:t>
+              <a:rPr>
+                <a:solidFill>
+                  <a:srgbClr val="000000"/>
+                </a:solidFill>
+              </a:rPr>
+              <a:t>Django admin provides full control over all data. Admins can manage exercises, users, orders, and content.</a:t>
             </a:r>
           </a:p>
         </p:txBody>
@@ -1358,7 +1418,12 @@
           <a:lstStyle/>
           <a:p>
             <a:r>
-              <a:t>Tech stack: Django 5.0 backend, SQLite database, HTML/CSS/JavaScript frontend, Groq AI API with Whisper and Orpheus, and Git/GitHub for version control.</a:t>
+              <a:rPr>
+                <a:solidFill>
+                  <a:srgbClr val="000000"/>
+                </a:solidFill>
+              </a:rPr>
+              <a:t>Tech stack: Django 5.0 backend, SQLite database, Groq AI API for the chatbot, Stripe for payments, standard web frontend, and Git/GitHub for collaboration.</a:t>
             </a:r>
           </a:p>
         </p:txBody>
@@ -1428,7 +1493,12 @@
           <a:lstStyle/>
           <a:p>
             <a:r>
-              <a:t>Fitness Hub is an all-in-one web app that brings together workout tracking, nutrition logging, goal setting, and social motivation in one place.</a:t>
+              <a:rPr>
+                <a:solidFill>
+                  <a:srgbClr val="000000"/>
+                </a:solidFill>
+              </a:rPr>
+              <a:t>Fitness Hub is an all-in-one web app that brings together workout tracking, nutrition logging, goal setting, and social motivation in one platform.</a:t>
             </a:r>
           </a:p>
         </p:txBody>
@@ -1498,7 +1568,12 @@
           <a:lstStyle/>
           <a:p>
             <a:r>
-              <a:t>Thank you for your attention. We're proud of what we've built at Shivapuri Secondary School. The repo is available at github.com/FitHub-4/Fitness-Hub. We welcome your questions and feedback.</a:t>
+              <a:rPr>
+                <a:solidFill>
+                  <a:srgbClr val="000000"/>
+                </a:solidFill>
+              </a:rPr>
+              <a:t>Thank you for your attention. The project is live at FitnessHub123.pythonanywhere.com and the code is on GitHub at github.com/FitHub-4/Fitness-Hub. We welcome your questions and feedback.</a:t>
             </a:r>
           </a:p>
         </p:txBody>
@@ -1568,7 +1643,12 @@
           <a:lstStyle/>
           <a:p>
             <a:r>
-              <a:t>Our objectives were both technical and educational - to build a real app while learning full-stack development and teamwork.</a:t>
+              <a:rPr>
+                <a:solidFill>
+                  <a:srgbClr val="000000"/>
+                </a:solidFill>
+              </a:rPr>
+              <a:t>Our objectives combined technical learning with practical outcomes: build a real app, learn Django, and gain teamwork experience.</a:t>
             </a:r>
           </a:p>
         </p:txBody>
@@ -1638,7 +1718,12 @@
           <a:lstStyle/>
           <a:p>
             <a:r>
-              <a:t>Django's MTV architecture separates concerns: Models for data, Templates for UI, Views for logic. This makes the codebase organized and scalable.</a:t>
+              <a:rPr>
+                <a:solidFill>
+                  <a:srgbClr val="000000"/>
+                </a:solidFill>
+              </a:rPr>
+              <a:t>Django's MTV architecture separates concerns: Models for data, Templates for UI, Views for logic. This keeps the codebase organized.</a:t>
             </a:r>
           </a:p>
         </p:txBody>
@@ -4862,6 +4947,220 @@
 </p:sld>
 </file>
 
+<file path=ppt/slides/slide10.xml><?xml version="1.0" encoding="utf-8"?>
+<p:sld xmlns:a="http://schemas.openxmlformats.org/drawingml/2006/main" xmlns:p="http://schemas.openxmlformats.org/presentationml/2006/main" xmlns:r="http://schemas.openxmlformats.org/officeDocument/2006/relationships">
+  <p:cSld>
+    <p:spTree>
+      <p:nvGrpSpPr>
+        <p:cNvPr id="1" name=""/>
+        <p:cNvGrpSpPr/>
+        <p:nvPr/>
+      </p:nvGrpSpPr>
+      <p:grpSpPr/>
+      <p:sp>
+        <p:nvSpPr>
+          <p:cNvPr id="2" name="TextBox 1"/>
+          <p:cNvSpPr txBox="1"/>
+          <p:nvPr/>
+        </p:nvSpPr>
+        <p:spPr>
+          <a:xfrm>
+            <a:off x="457200" y="228600"/>
+            <a:ext cx="10972800" cy="731520"/>
+          </a:xfrm>
+          <a:prstGeom prst="rect">
+            <a:avLst/>
+          </a:prstGeom>
+          <a:noFill/>
+        </p:spPr>
+        <p:txBody>
+          <a:bodyPr wrap="none">
+            <a:spAutoFit/>
+          </a:bodyPr>
+          <a:lstStyle/>
+          <a:p>
+            <a:pPr>
+              <a:defRPr sz="2800" b="1">
+                <a:solidFill>
+                  <a:srgbClr val="000000"/>
+                </a:solidFill>
+              </a:defRPr>
+            </a:pPr>
+            <a:r>
+              <a:t>Progress Tracking</a:t>
+              <a:rPr>
+                <a:solidFill>
+                  <a:srgbClr val="000000"/>
+                </a:solidFill>
+              </a:rPr>
+            </a:r>
+          </a:p>
+        </p:txBody>
+      </p:sp>
+      <p:sp>
+        <p:nvSpPr>
+          <p:cNvPr id="3" name="TextBox 2"/>
+          <p:cNvSpPr txBox="1"/>
+          <p:nvPr/>
+        </p:nvSpPr>
+        <p:spPr>
+          <a:xfrm>
+            <a:off x="457200" y="1005840"/>
+            <a:ext cx="10972800" cy="5303520"/>
+          </a:xfrm>
+          <a:prstGeom prst="rect">
+            <a:avLst/>
+          </a:prstGeom>
+          <a:noFill/>
+        </p:spPr>
+        <p:txBody>
+          <a:bodyPr wrap="square">
+            <a:spAutoFit/>
+          </a:bodyPr>
+          <a:lstStyle/>
+          <a:p>
+            <a:pPr>
+              <a:spcAft>
+                <a:spcPts val="1000"/>
+              </a:spcAft>
+              <a:defRPr sz="1600">
+                <a:solidFill>
+                  <a:srgbClr val="000000"/>
+                </a:solidFill>
+              </a:defRPr>
+            </a:pPr>
+            <a:r>
+              <a:rPr>
+                <a:sz val="1600"/>
+                <a:solidFill>
+                  <a:srgbClr val="000000"/>
+                </a:solidFill>
+              </a:rPr>
+              <a:t>• Progress page logs exercise completions with reps and notes.</a:t>
+            </a:r>
+          </a:p>
+          <a:p>
+            <a:pPr>
+              <a:spcAft>
+                <a:spcPts val="1000"/>
+              </a:spcAft>
+              <a:defRPr sz="1600">
+                <a:solidFill>
+                  <a:srgbClr val="000000"/>
+                </a:solidFill>
+              </a:defRPr>
+            </a:pPr>
+            <a:r>
+              <a:rPr>
+                <a:sz val="1600"/>
+                <a:solidFill>
+                  <a:srgbClr val="000000"/>
+                </a:solidFill>
+              </a:rPr>
+              <a:t>• Workout streaks count consecutive days of training.</a:t>
+            </a:r>
+          </a:p>
+          <a:p>
+            <a:pPr>
+              <a:spcAft>
+                <a:spcPts val="1000"/>
+              </a:spcAft>
+              <a:defRPr sz="1600">
+                <a:solidFill>
+                  <a:srgbClr val="000000"/>
+                </a:solidFill>
+              </a:defRPr>
+            </a:pPr>
+            <a:r>
+              <a:rPr>
+                <a:sz val="1600"/>
+                <a:solidFill>
+                  <a:srgbClr val="000000"/>
+                </a:solidFill>
+              </a:rPr>
+              <a:t>• Volume trend shows total reps over the last seven days.</a:t>
+            </a:r>
+          </a:p>
+          <a:p>
+            <a:pPr>
+              <a:spcAft>
+                <a:spcPts val="1000"/>
+              </a:spcAft>
+              <a:defRPr sz="1600">
+                <a:solidFill>
+                  <a:srgbClr val="000000"/>
+                </a:solidFill>
+              </a:defRPr>
+            </a:pPr>
+            <a:r>
+              <a:rPr>
+                <a:sz val="1600"/>
+                <a:solidFill>
+                  <a:srgbClr val="000000"/>
+                </a:solidFill>
+              </a:rPr>
+              <a:t>• Track body weight, fat, waist, chest, and arm measurements.</a:t>
+            </a:r>
+          </a:p>
+          <a:p>
+            <a:pPr>
+              <a:spcAft>
+                <a:spcPts val="1000"/>
+              </a:spcAft>
+              <a:defRPr sz="1600">
+                <a:solidFill>
+                  <a:srgbClr val="000000"/>
+                </a:solidFill>
+              </a:defRPr>
+            </a:pPr>
+            <a:r>
+              <a:rPr>
+                <a:sz val="1600"/>
+                <a:solidFill>
+                  <a:srgbClr val="000000"/>
+                </a:solidFill>
+              </a:rPr>
+              <a:t>• Get suggestions for exercises based on your current goal.</a:t>
+            </a:r>
+          </a:p>
+          <a:p>
+            <a:pPr>
+              <a:spcAft>
+                <a:spcPts val="1000"/>
+              </a:spcAft>
+              <a:defRPr sz="1600">
+                <a:solidFill>
+                  <a:srgbClr val="000000"/>
+                </a:solidFill>
+              </a:defRPr>
+            </a:pPr>
+            <a:r>
+              <a:rPr>
+                <a:sz val="1600"/>
+                <a:solidFill>
+                  <a:srgbClr val="000000"/>
+                </a:solidFill>
+              </a:rPr>
+              <a:t>• Weekly feedback message encourages your progress.</a:t>
+            </a:r>
+          </a:p>
+        </p:txBody>
+      </p:sp>
+    </p:spTree>
+    <p:bg>
+      <p:bgPr>
+        <a:solidFill>
+          <a:srgbClr val="FFFFFF"/>
+        </a:solidFill>
+      </p:bgPr>
+    </p:bg>
+  </p:cSld>
+  <p:clrMapOvr>
+    <a:masterClrMapping/>
+  </p:clrMapOvr>
+</p:sld>
+</file>
+
 <file path=ppt/slides/slide11.xml><?xml version="1.0" encoding="utf-8"?>
 <p:sld xmlns:a="http://schemas.openxmlformats.org/drawingml/2006/main" xmlns:p="http://schemas.openxmlformats.org/presentationml/2006/main" xmlns:r="http://schemas.openxmlformats.org/officeDocument/2006/relationships">
   <p:cSld>
@@ -4902,7 +5201,7 @@
               </a:defRPr>
             </a:pPr>
             <a:r>
-              <a:t>Login and Signup</a:t>
+              <a:t>Diet and Nutrition</a:t>
               <a:rPr>
                 <a:solidFill>
                   <a:srgbClr val="000000"/>
@@ -4945,112 +5244,118 @@
               </a:defRPr>
             </a:pPr>
             <a:r>
-              <a:t>• New users create accounts using username, email, password, age, height, and.</a:t>
-              <a:rPr>
-                <a:solidFill>
-                  <a:srgbClr val="000000"/>
-                </a:solidFill>
-              </a:rPr>
-            </a:r>
-          </a:p>
-          <a:p>
-            <a:pPr>
-              <a:spcAft>
-                <a:spcPts val="1000"/>
-              </a:spcAft>
-              <a:defRPr sz="1600">
-                <a:solidFill>
-                  <a:srgbClr val="000000"/>
-                </a:solidFill>
-              </a:defRPr>
-            </a:pPr>
-            <a:r>
-              <a:t>• Registration automatically creates a Profile object linked to the new user.</a:t>
-              <a:rPr>
-                <a:solidFill>
-                  <a:srgbClr val="000000"/>
-                </a:solidFill>
-              </a:rPr>
-            </a:r>
-          </a:p>
-          <a:p>
-            <a:pPr>
-              <a:spcAft>
-                <a:spcPts val="1000"/>
-              </a:spcAft>
-              <a:defRPr sz="1600">
-                <a:solidFill>
-                  <a:srgbClr val="000000"/>
-                </a:solidFill>
-              </a:defRPr>
-            </a:pPr>
-            <a:r>
-              <a:t>• Returning users log in with username and password to access their.</a:t>
-              <a:rPr>
-                <a:solidFill>
-                  <a:srgbClr val="000000"/>
-                </a:solidFill>
-              </a:rPr>
-            </a:r>
-          </a:p>
-          <a:p>
-            <a:pPr>
-              <a:spcAft>
-                <a:spcPts val="1000"/>
-              </a:spcAft>
-              <a:defRPr sz="1600">
-                <a:solidFill>
-                  <a:srgbClr val="000000"/>
-                </a:solidFill>
-              </a:defRPr>
-            </a:pPr>
-            <a:r>
-              <a:t>• Login page displays motivational quotes and workout statistics for inspiration.</a:t>
-              <a:rPr>
-                <a:solidFill>
-                  <a:srgbClr val="000000"/>
-                </a:solidFill>
-              </a:rPr>
-            </a:r>
-          </a:p>
-          <a:p>
-            <a:pPr>
-              <a:spcAft>
-                <a:spcPts val="1000"/>
-              </a:spcAft>
-              <a:defRPr sz="1600">
-                <a:solidFill>
-                  <a:srgbClr val="000000"/>
-                </a:solidFill>
-              </a:defRPr>
-            </a:pPr>
-            <a:r>
-              <a:t>• Password reset helps users recover accounts if they forget their login.</a:t>
-              <a:rPr>
-                <a:solidFill>
-                  <a:srgbClr val="000000"/>
-                </a:solidFill>
-              </a:rPr>
-            </a:r>
-          </a:p>
-          <a:p>
-            <a:pPr>
-              <a:spcAft>
-                <a:spcPts val="1000"/>
-              </a:spcAft>
-              <a:defRPr sz="1600">
-                <a:solidFill>
-                  <a:srgbClr val="000000"/>
-                </a:solidFill>
-              </a:defRPr>
-            </a:pPr>
-            <a:r>
-              <a:t>• All authentication uses Django built-in forms with CSRF protection always.</a:t>
-              <a:rPr>
-                <a:solidFill>
-                  <a:srgbClr val="000000"/>
-                </a:solidFill>
-              </a:rPr>
+              <a:rPr>
+                <a:sz val="1600"/>
+                <a:solidFill>
+                  <a:srgbClr val="000000"/>
+                </a:solidFill>
+              </a:rPr>
+              <a:t>• Log daily calories, protein, carbs, and fats intake.</a:t>
+            </a:r>
+          </a:p>
+          <a:p>
+            <a:pPr>
+              <a:spcAft>
+                <a:spcPts val="1000"/>
+              </a:spcAft>
+              <a:defRPr sz="1600">
+                <a:solidFill>
+                  <a:srgbClr val="000000"/>
+                </a:solidFill>
+              </a:defRPr>
+            </a:pPr>
+            <a:r>
+              <a:rPr>
+                <a:sz val="1600"/>
+                <a:solidFill>
+                  <a:srgbClr val="000000"/>
+                </a:solidFill>
+              </a:rPr>
+              <a:t>• BMR and TDEE calculator estimates your energy needs.</a:t>
+            </a:r>
+          </a:p>
+          <a:p>
+            <a:pPr>
+              <a:spcAft>
+                <a:spcPts val="1000"/>
+              </a:spcAft>
+              <a:defRPr sz="1600">
+                <a:solidFill>
+                  <a:srgbClr val="000000"/>
+                </a:solidFill>
+              </a:defRPr>
+            </a:pPr>
+            <a:r>
+              <a:rPr>
+                <a:sz val="1600"/>
+                <a:solidFill>
+                  <a:srgbClr val="000000"/>
+                </a:solidFill>
+              </a:rPr>
+              <a:t>• Macro calculator splits calories into protein and carbs.</a:t>
+            </a:r>
+          </a:p>
+          <a:p>
+            <a:pPr>
+              <a:spcAft>
+                <a:spcPts val="1000"/>
+              </a:spcAft>
+              <a:defRPr sz="1600">
+                <a:solidFill>
+                  <a:srgbClr val="000000"/>
+                </a:solidFill>
+              </a:defRPr>
+            </a:pPr>
+            <a:r>
+              <a:rPr>
+                <a:sz val="1600"/>
+                <a:solidFill>
+                  <a:srgbClr val="000000"/>
+                </a:solidFill>
+              </a:rPr>
+              <a:t>• Browse affordable foods with complete nutritional info.</a:t>
+            </a:r>
+          </a:p>
+          <a:p>
+            <a:pPr>
+              <a:spcAft>
+                <a:spcPts val="1000"/>
+              </a:spcAft>
+              <a:defRPr sz="1600">
+                <a:solidFill>
+                  <a:srgbClr val="000000"/>
+                </a:solidFill>
+              </a:defRPr>
+            </a:pPr>
+            <a:r>
+              <a:rPr>
+                <a:sz val="1600"/>
+                <a:solidFill>
+                  <a:srgbClr val="000000"/>
+                </a:solidFill>
+              </a:rPr>
+              <a:t>• Budget meal plans with calculated macro totals provided.</a:t>
+            </a:r>
+          </a:p>
+          <a:p>
+            <a:pPr>
+              <a:spcAft>
+                <a:spcPts val="1000"/>
+              </a:spcAft>
+              <a:defRPr sz="1600">
+                <a:solidFill>
+                  <a:srgbClr val="000000"/>
+                </a:solidFill>
+              </a:defRPr>
+            </a:pPr>
+            <a:r>
+              <a:rPr>
+                <a:sz val="1600"/>
+                <a:solidFill>
+                  <a:srgbClr val="000000"/>
+                </a:solidFill>
+              </a:rPr>
+              <a:t>• Get weekly meal suggestions based on your fitness goals.</a:t>
             </a:r>
           </a:p>
         </p:txBody>
@@ -5110,7 +5415,7 @@
               </a:defRPr>
             </a:pPr>
             <a:r>
-              <a:t>Your Personal Dashboard</a:t>
+              <a:t>Store and Shopping</a:t>
               <a:rPr>
                 <a:solidFill>
                   <a:srgbClr val="000000"/>
@@ -5153,112 +5458,118 @@
               </a:defRPr>
             </a:pPr>
             <a:r>
-              <a:t>• Dashboard shows goal readiness percentage and next recommended exercise daily.</a:t>
-              <a:rPr>
-                <a:solidFill>
-                  <a:srgbClr val="000000"/>
-                </a:solidFill>
-              </a:rPr>
-            </a:r>
-          </a:p>
-          <a:p>
-            <a:pPr>
-              <a:spcAft>
-                <a:spcPts val="1000"/>
-              </a:spcAft>
-              <a:defRPr sz="1600">
-                <a:solidFill>
-                  <a:srgbClr val="000000"/>
-                </a:solidFill>
-              </a:defRPr>
-            </a:pPr>
-            <a:r>
-              <a:t>• Weekly completion count tracks how many workouts the user finished recently.</a:t>
-              <a:rPr>
-                <a:solidFill>
-                  <a:srgbClr val="000000"/>
-                </a:solidFill>
-              </a:rPr>
-            </a:r>
-          </a:p>
-          <a:p>
-            <a:pPr>
-              <a:spcAft>
-                <a:spcPts val="1000"/>
-              </a:spcAft>
-              <a:defRPr sz="1600">
-                <a:solidFill>
-                  <a:srgbClr val="000000"/>
-                </a:solidFill>
-              </a:defRPr>
-            </a:pPr>
-            <a:r>
-              <a:t>• Recent completions display the last ten finished exercises with dates clearly.</a:t>
-              <a:rPr>
-                <a:solidFill>
-                  <a:srgbClr val="000000"/>
-                </a:solidFill>
-              </a:rPr>
-            </a:r>
-          </a:p>
-          <a:p>
-            <a:pPr>
-              <a:spcAft>
-                <a:spcPts val="1000"/>
-              </a:spcAft>
-              <a:defRPr sz="1600">
-                <a:solidFill>
-                  <a:srgbClr val="000000"/>
-                </a:solidFill>
-              </a:defRPr>
-            </a:pPr>
-            <a:r>
-              <a:t>• Focus alignment message gives personalized feedback based on user goal progress.</a:t>
-              <a:rPr>
-                <a:solidFill>
-                  <a:srgbClr val="000000"/>
-                </a:solidFill>
-              </a:rPr>
-            </a:r>
-          </a:p>
-          <a:p>
-            <a:pPr>
-              <a:spcAft>
-                <a:spcPts val="1000"/>
-              </a:spcAft>
-              <a:defRPr sz="1600">
-                <a:solidFill>
-                  <a:srgbClr val="000000"/>
-                </a:solidFill>
-              </a:defRPr>
-            </a:pPr>
-            <a:r>
-              <a:t>• Workout stats show total sessions, current streak, and longest streak achieved.</a:t>
-              <a:rPr>
-                <a:solidFill>
-                  <a:srgbClr val="000000"/>
-                </a:solidFill>
-              </a:rPr>
-            </a:r>
-          </a:p>
-          <a:p>
-            <a:pPr>
-              <a:spcAft>
-                <a:spcPts val="1000"/>
-              </a:spcAft>
-              <a:defRPr sz="1600">
-                <a:solidFill>
-                  <a:srgbClr val="000000"/>
-                </a:solidFill>
-              </a:defRPr>
-            </a:pPr>
-            <a:r>
-              <a:t>• Quick access cards navigate to exercises, goals, diet, and social features.</a:t>
-              <a:rPr>
-                <a:solidFill>
-                  <a:srgbClr val="000000"/>
-                </a:solidFill>
-              </a:rPr>
+              <a:rPr>
+                <a:sz val="1600"/>
+                <a:solidFill>
+                  <a:srgbClr val="000000"/>
+                </a:solidFill>
+              </a:rPr>
+              <a:t>• Store has three categories: Outfits, Gear, Supplements.</a:t>
+            </a:r>
+          </a:p>
+          <a:p>
+            <a:pPr>
+              <a:spcAft>
+                <a:spcPts val="1000"/>
+              </a:spcAft>
+              <a:defRPr sz="1600">
+                <a:solidFill>
+                  <a:srgbClr val="000000"/>
+                </a:solidFill>
+              </a:defRPr>
+            </a:pPr>
+            <a:r>
+              <a:rPr>
+                <a:sz val="1600"/>
+                <a:solidFill>
+                  <a:srgbClr val="000000"/>
+                </a:solidFill>
+              </a:rPr>
+              <a:t>• 12 products with prices, descriptions, and stock counts.</a:t>
+            </a:r>
+          </a:p>
+          <a:p>
+            <a:pPr>
+              <a:spcAft>
+                <a:spcPts val="1000"/>
+              </a:spcAft>
+              <a:defRPr sz="1600">
+                <a:solidFill>
+                  <a:srgbClr val="000000"/>
+                </a:solidFill>
+              </a:defRPr>
+            </a:pPr>
+            <a:r>
+              <a:rPr>
+                <a:sz val="1600"/>
+                <a:solidFill>
+                  <a:srgbClr val="000000"/>
+                </a:solidFill>
+              </a:rPr>
+              <a:t>• Cart works for both logged-in and guest users.</a:t>
+            </a:r>
+          </a:p>
+          <a:p>
+            <a:pPr>
+              <a:spcAft>
+                <a:spcPts val="1000"/>
+              </a:spcAft>
+              <a:defRPr sz="1600">
+                <a:solidFill>
+                  <a:srgbClr val="000000"/>
+                </a:solidFill>
+              </a:defRPr>
+            </a:pPr>
+            <a:r>
+              <a:rPr>
+                <a:sz val="1600"/>
+                <a:solidFill>
+                  <a:srgbClr val="000000"/>
+                </a:solidFill>
+              </a:rPr>
+              <a:t>• Checkout prevents overselling with atomic stock updates.</a:t>
+            </a:r>
+          </a:p>
+          <a:p>
+            <a:pPr>
+              <a:spcAft>
+                <a:spcPts val="1000"/>
+              </a:spcAft>
+              <a:defRPr sz="1600">
+                <a:solidFill>
+                  <a:srgbClr val="000000"/>
+                </a:solidFill>
+              </a:defRPr>
+            </a:pPr>
+            <a:r>
+              <a:rPr>
+                <a:sz val="1600"/>
+                <a:solidFill>
+                  <a:srgbClr val="000000"/>
+                </a:solidFill>
+              </a:rPr>
+              <a:t>• Order history tracks your purchases and delivery status.</a:t>
+            </a:r>
+          </a:p>
+          <a:p>
+            <a:pPr>
+              <a:spcAft>
+                <a:spcPts val="1000"/>
+              </a:spcAft>
+              <a:defRPr sz="1600">
+                <a:solidFill>
+                  <a:srgbClr val="000000"/>
+                </a:solidFill>
+              </a:defRPr>
+            </a:pPr>
+            <a:r>
+              <a:rPr>
+                <a:sz val="1600"/>
+                <a:solidFill>
+                  <a:srgbClr val="000000"/>
+                </a:solidFill>
+              </a:rPr>
+              <a:t>• Free shipping on orders over five thousand rupees.</a:t>
             </a:r>
           </a:p>
         </p:txBody>
@@ -5318,7 +5629,7 @@
               </a:defRPr>
             </a:pPr>
             <a:r>
-              <a:t>Workout Library</a:t>
+              <a:t>Inspiration and Motivation</a:t>
               <a:rPr>
                 <a:solidFill>
                   <a:srgbClr val="000000"/>
@@ -5361,112 +5672,118 @@
               </a:defRPr>
             </a:pPr>
             <a:r>
-              <a:t>• Exercise library contains thirty-six exercises across seven muscle group categories.</a:t>
-              <a:rPr>
-                <a:solidFill>
-                  <a:srgbClr val="000000"/>
-                </a:solidFill>
-              </a:rPr>
-            </a:r>
-          </a:p>
-          <a:p>
-            <a:pPr>
-              <a:spcAft>
-                <a:spcPts val="1000"/>
-              </a:spcAft>
-              <a:defRPr sz="1600">
-                <a:solidFill>
-                  <a:srgbClr val="000000"/>
-                </a:solidFill>
-              </a:defRPr>
-            </a:pPr>
-            <a:r>
-              <a:t>• Categories include chest, back, shoulders, arms, legs, core, and cardio types.</a:t>
-              <a:rPr>
-                <a:solidFill>
-                  <a:srgbClr val="000000"/>
-                </a:solidFill>
-              </a:rPr>
-            </a:r>
-          </a:p>
-          <a:p>
-            <a:pPr>
-              <a:spcAft>
-                <a:spcPts val="1000"/>
-              </a:spcAft>
-              <a:defRPr sz="1600">
-                <a:solidFill>
-                  <a:srgbClr val="000000"/>
-                </a:solidFill>
-              </a:defRPr>
-            </a:pPr>
-            <a:r>
-              <a:t>• Each exercise stores name, description, steps, form tips, breathing, and safety.</a:t>
-              <a:rPr>
-                <a:solidFill>
-                  <a:srgbClr val="000000"/>
-                </a:solidFill>
-              </a:rPr>
-            </a:r>
-          </a:p>
-          <a:p>
-            <a:pPr>
-              <a:spcAft>
-                <a:spcPts val="1000"/>
-              </a:spcAft>
-              <a:defRPr sz="1600">
-                <a:solidFill>
-                  <a:srgbClr val="000000"/>
-                </a:solidFill>
-              </a:defRPr>
-            </a:pPr>
-            <a:r>
-              <a:t>• Users can filter exercises by goal type, difficulty level, and required.</a:t>
-              <a:rPr>
-                <a:solidFill>
-                  <a:srgbClr val="000000"/>
-                </a:solidFill>
-              </a:rPr>
-            </a:r>
-          </a:p>
-          <a:p>
-            <a:pPr>
-              <a:spcAft>
-                <a:spcPts val="1000"/>
-              </a:spcAft>
-              <a:defRPr sz="1600">
-                <a:solidFill>
-                  <a:srgbClr val="000000"/>
-                </a:solidFill>
-              </a:defRPr>
-            </a:pPr>
-            <a:r>
-              <a:t>• Exercise detail page shows default reps, sets, duration, and calories per.</a:t>
-              <a:rPr>
-                <a:solidFill>
-                  <a:srgbClr val="000000"/>
-                </a:solidFill>
-              </a:rPr>
-            </a:r>
-          </a:p>
-          <a:p>
-            <a:pPr>
-              <a:spcAft>
-                <a:spcPts val="1000"/>
-              </a:spcAft>
-              <a:defRPr sz="1600">
-                <a:solidFill>
-                  <a:srgbClr val="000000"/>
-                </a:solidFill>
-              </a:defRPr>
-            </a:pPr>
-            <a:r>
-              <a:t>• Home page highlights featured workouts and provides quick links to library.</a:t>
-              <a:rPr>
-                <a:solidFill>
-                  <a:srgbClr val="000000"/>
-                </a:solidFill>
-              </a:rPr>
+              <a:rPr>
+                <a:sz val="1600"/>
+                <a:solidFill>
+                  <a:srgbClr val="000000"/>
+                </a:solidFill>
+              </a:rPr>
+              <a:t>• Get inspired by 23 famous fitness personalities.</a:t>
+            </a:r>
+          </a:p>
+          <a:p>
+            <a:pPr>
+              <a:spcAft>
+                <a:spcPts val="1000"/>
+              </a:spcAft>
+              <a:defRPr sz="1600">
+                <a:solidFill>
+                  <a:srgbClr val="000000"/>
+                </a:solidFill>
+              </a:defRPr>
+            </a:pPr>
+            <a:r>
+              <a:rPr>
+                <a:sz val="1600"/>
+                <a:solidFill>
+                  <a:srgbClr val="000000"/>
+                </a:solidFill>
+              </a:rPr>
+              <a:t>• Read their stories, tips, and watch YouTube videos.</a:t>
+            </a:r>
+          </a:p>
+          <a:p>
+            <a:pPr>
+              <a:spcAft>
+                <a:spcPts val="1000"/>
+              </a:spcAft>
+              <a:defRPr sz="1600">
+                <a:solidFill>
+                  <a:srgbClr val="000000"/>
+                </a:solidFill>
+              </a:defRPr>
+            </a:pPr>
+            <a:r>
+              <a:rPr>
+                <a:sz val="1600"/>
+                <a:solidFill>
+                  <a:srgbClr val="000000"/>
+                </a:solidFill>
+              </a:rPr>
+              <a:t>• Daily motivation quotes rotate from 88 saved quotes.</a:t>
+            </a:r>
+          </a:p>
+          <a:p>
+            <a:pPr>
+              <a:spcAft>
+                <a:spcPts val="1000"/>
+              </a:spcAft>
+              <a:defRPr sz="1600">
+                <a:solidFill>
+                  <a:srgbClr val="000000"/>
+                </a:solidFill>
+              </a:defRPr>
+            </a:pPr>
+            <a:r>
+              <a:rPr>
+                <a:sz val="1600"/>
+                <a:solidFill>
+                  <a:srgbClr val="000000"/>
+                </a:solidFill>
+              </a:rPr>
+              <a:t>• Browse quotes by category like bodybuilding or athletics.</a:t>
+            </a:r>
+          </a:p>
+          <a:p>
+            <a:pPr>
+              <a:spcAft>
+                <a:spcPts val="1000"/>
+              </a:spcAft>
+              <a:defRPr sz="1600">
+                <a:solidFill>
+                  <a:srgbClr val="000000"/>
+                </a:solidFill>
+              </a:defRPr>
+            </a:pPr>
+            <a:r>
+              <a:rPr>
+                <a:sz val="1600"/>
+                <a:solidFill>
+                  <a:srgbClr val="000000"/>
+                </a:solidFill>
+              </a:rPr>
+              <a:t>• Use the quote wall to find motivation anytime.</a:t>
+            </a:r>
+          </a:p>
+          <a:p>
+            <a:pPr>
+              <a:spcAft>
+                <a:spcPts val="1000"/>
+              </a:spcAft>
+              <a:defRPr sz="1600">
+                <a:solidFill>
+                  <a:srgbClr val="000000"/>
+                </a:solidFill>
+              </a:defRPr>
+            </a:pPr>
+            <a:r>
+              <a:rPr>
+                <a:sz val="1600"/>
+                <a:solidFill>
+                  <a:srgbClr val="000000"/>
+                </a:solidFill>
+              </a:rPr>
+              <a:t>• Random quote feature delivers fresh inspiration daily.</a:t>
             </a:r>
           </a:p>
         </p:txBody>
@@ -5526,7 +5843,7 @@
               </a:defRPr>
             </a:pPr>
             <a:r>
-              <a:t>Setting and Tracking Goals</a:t>
+              <a:t>Social Features</a:t>
               <a:rPr>
                 <a:solidFill>
                   <a:srgbClr val="000000"/>
@@ -5569,112 +5886,118 @@
               </a:defRPr>
             </a:pPr>
             <a:r>
-              <a:t>• Users create custom goals with type, target weight, timeline, and description.</a:t>
-              <a:rPr>
-                <a:solidFill>
-                  <a:srgbClr val="000000"/>
-                </a:solidFill>
-              </a:rPr>
-            </a:r>
-          </a:p>
-          <a:p>
-            <a:pPr>
-              <a:spcAft>
-                <a:spcPts val="1000"/>
-              </a:spcAft>
-              <a:defRPr sz="1600">
-                <a:solidFill>
-                  <a:srgbClr val="000000"/>
-                </a:solidFill>
-              </a:defRPr>
-            </a:pPr>
-            <a:r>
-              <a:t>• Eight goal types include calisthenics, lean athletic, muscle gain, and fat.</a:t>
-              <a:rPr>
-                <a:solidFill>
-                  <a:srgbClr val="000000"/>
-                </a:solidFill>
-              </a:rPr>
-            </a:r>
-          </a:p>
-          <a:p>
-            <a:pPr>
-              <a:spcAft>
-                <a:spcPts val="1000"/>
-              </a:spcAft>
-              <a:defRPr sz="1600">
-                <a:solidFill>
-                  <a:srgbClr val="000000"/>
-                </a:solidFill>
-              </a:defRPr>
-            </a:pPr>
-            <a:r>
-              <a:t>• Focus areas let users target upper body, lower body, core, pull,.</a:t>
-              <a:rPr>
-                <a:solidFill>
-                  <a:srgbClr val="000000"/>
-                </a:solidFill>
-              </a:rPr>
-            </a:r>
-          </a:p>
-          <a:p>
-            <a:pPr>
-              <a:spcAft>
-                <a:spcPts val="1000"/>
-              </a:spcAft>
-              <a:defRPr sz="1600">
-                <a:solidFill>
-                  <a:srgbClr val="000000"/>
-                </a:solidFill>
-              </a:defRPr>
-            </a:pPr>
-            <a:r>
-              <a:t>• System auto-assigns exercises based on goal type using database query filters.</a:t>
-              <a:rPr>
-                <a:solidFill>
-                  <a:srgbClr val="000000"/>
-                </a:solidFill>
-              </a:rPr>
-            </a:r>
-          </a:p>
-          <a:p>
-            <a:pPr>
-              <a:spcAft>
-                <a:spcPts val="1000"/>
-              </a:spcAft>
-              <a:defRPr sz="1600">
-                <a:solidFill>
-                  <a:srgbClr val="000000"/>
-                </a:solidFill>
-              </a:defRPr>
-            </a:pPr>
-            <a:r>
-              <a:t>• Progress percentage updates as users complete assigned exercises over time.</a:t>
-              <a:rPr>
-                <a:solidFill>
-                  <a:srgbClr val="000000"/>
-                </a:solidFill>
-              </a:rPr>
-            </a:r>
-          </a:p>
-          <a:p>
-            <a:pPr>
-              <a:spcAft>
-                <a:spcPts val="1000"/>
-              </a:spcAft>
-              <a:defRPr sz="1600">
-                <a:solidFill>
-                  <a:srgbClr val="000000"/>
-                </a:solidFill>
-              </a:defRPr>
-            </a:pPr>
-            <a:r>
-              <a:t>• Goals sync from profile selection so dashboard and progress stay consistent.</a:t>
-              <a:rPr>
-                <a:solidFill>
-                  <a:srgbClr val="000000"/>
-                </a:solidFill>
-              </a:rPr>
+              <a:rPr>
+                <a:sz val="1600"/>
+                <a:solidFill>
+                  <a:srgbClr val="000000"/>
+                </a:solidFill>
+              </a:rPr>
+              <a:t>• Connect with friends as workout partners or rivals.</a:t>
+            </a:r>
+          </a:p>
+          <a:p>
+            <a:pPr>
+              <a:spcAft>
+                <a:spcPts val="1000"/>
+              </a:spcAft>
+              <a:defRPr sz="1600">
+                <a:solidFill>
+                  <a:srgbClr val="000000"/>
+                </a:solidFill>
+              </a:defRPr>
+            </a:pPr>
+            <a:r>
+              <a:rPr>
+                <a:sz val="1600"/>
+                <a:solidFill>
+                  <a:srgbClr val="000000"/>
+                </a:solidFill>
+              </a:rPr>
+              <a:t>• Send and accept friend requests easily.</a:t>
+            </a:r>
+          </a:p>
+          <a:p>
+            <a:pPr>
+              <a:spcAft>
+                <a:spcPts val="1000"/>
+              </a:spcAft>
+              <a:defRPr sz="1600">
+                <a:solidFill>
+                  <a:srgbClr val="000000"/>
+                </a:solidFill>
+              </a:defRPr>
+            </a:pPr>
+            <a:r>
+              <a:rPr>
+                <a:sz val="1600"/>
+                <a:solidFill>
+                  <a:srgbClr val="000000"/>
+                </a:solidFill>
+              </a:rPr>
+              <a:t>• Chat privately with your connected friends.</a:t>
+            </a:r>
+          </a:p>
+          <a:p>
+            <a:pPr>
+              <a:spcAft>
+                <a:spcPts val="1000"/>
+              </a:spcAft>
+              <a:defRPr sz="1600">
+                <a:solidFill>
+                  <a:srgbClr val="000000"/>
+                </a:solidFill>
+              </a:defRPr>
+            </a:pPr>
+            <a:r>
+              <a:rPr>
+                <a:sz val="1600"/>
+                <a:solidFill>
+                  <a:srgbClr val="000000"/>
+                </a:solidFill>
+              </a:rPr>
+              <a:t>• Messages show sender, time, and read status.</a:t>
+            </a:r>
+          </a:p>
+          <a:p>
+            <a:pPr>
+              <a:spcAft>
+                <a:spcPts val="1000"/>
+              </a:spcAft>
+              <a:defRPr sz="1600">
+                <a:solidFill>
+                  <a:srgbClr val="000000"/>
+                </a:solidFill>
+              </a:defRPr>
+            </a:pPr>
+            <a:r>
+              <a:rPr>
+                <a:sz val="1600"/>
+                <a:solidFill>
+                  <a:srgbClr val="000000"/>
+                </a:solidFill>
+              </a:rPr>
+              <a:t>• Search for other users by name or email.</a:t>
+            </a:r>
+          </a:p>
+          <a:p>
+            <a:pPr>
+              <a:spcAft>
+                <a:spcPts val="1000"/>
+              </a:spcAft>
+              <a:defRPr sz="1600">
+                <a:solidFill>
+                  <a:srgbClr val="000000"/>
+                </a:solidFill>
+              </a:defRPr>
+            </a:pPr>
+            <a:r>
+              <a:rPr>
+                <a:sz val="1600"/>
+                <a:solidFill>
+                  <a:srgbClr val="000000"/>
+                </a:solidFill>
+              </a:rPr>
+              <a:t>• Social hub shows all your connections and chats.</a:t>
             </a:r>
           </a:p>
         </p:txBody>
@@ -5734,7 +6057,7 @@
               </a:defRPr>
             </a:pPr>
             <a:r>
-              <a:t>Progress Tracking</a:t>
+              <a:t>Achievements System</a:t>
               <a:rPr>
                 <a:solidFill>
                   <a:srgbClr val="000000"/>
@@ -5777,112 +6100,118 @@
               </a:defRPr>
             </a:pPr>
             <a:r>
-              <a:t>• Progress page shows exercise completions with reps, hold time, and notes.</a:t>
-              <a:rPr>
-                <a:solidFill>
-                  <a:srgbClr val="000000"/>
-                </a:solidFill>
-              </a:rPr>
-            </a:r>
-          </a:p>
-          <a:p>
-            <a:pPr>
-              <a:spcAft>
-                <a:spcPts val="1000"/>
-              </a:spcAft>
-              <a:defRPr sz="1600">
-                <a:solidFill>
-                  <a:srgbClr val="000000"/>
-                </a:solidFill>
-              </a:defRPr>
-            </a:pPr>
-            <a:r>
-              <a:t>• Workout streaks count consecutive days and motivate users to keep training.</a:t>
-              <a:rPr>
-                <a:solidFill>
-                  <a:srgbClr val="000000"/>
-                </a:solidFill>
-              </a:rPr>
-            </a:r>
-          </a:p>
-          <a:p>
-            <a:pPr>
-              <a:spcAft>
-                <a:spcPts val="1000"/>
-              </a:spcAft>
-              <a:defRPr sz="1600">
-                <a:solidFill>
-                  <a:srgbClr val="000000"/>
-                </a:solidFill>
-              </a:defRPr>
-            </a:pPr>
-            <a:r>
-              <a:t>• Volume trend calculates total reps or hold time across seven-day rolling.</a:t>
-              <a:rPr>
-                <a:solidFill>
-                  <a:srgbClr val="000000"/>
-                </a:solidFill>
-              </a:rPr>
-            </a:r>
-          </a:p>
-          <a:p>
-            <a:pPr>
-              <a:spcAft>
-                <a:spcPts val="1000"/>
-              </a:spcAft>
-              <a:defRPr sz="1600">
-                <a:solidFill>
-                  <a:srgbClr val="000000"/>
-                </a:solidFill>
-              </a:defRPr>
-            </a:pPr>
-            <a:r>
-              <a:t>• Body metrics tracking records weight, body fat, waist, chest, and arm.</a:t>
-              <a:rPr>
-                <a:solidFill>
-                  <a:srgbClr val="000000"/>
-                </a:solidFill>
-              </a:rPr>
-            </a:r>
-          </a:p>
-          <a:p>
-            <a:pPr>
-              <a:spcAft>
-                <a:spcPts val="1000"/>
-              </a:spcAft>
-              <a:defRPr sz="1600">
-                <a:solidFill>
-                  <a:srgbClr val="000000"/>
-                </a:solidFill>
-              </a:defRPr>
-            </a:pPr>
-            <a:r>
-              <a:t>• Focus suggestions recommend specific exercises based on current goal benchmarks.</a:t>
-              <a:rPr>
-                <a:solidFill>
-                  <a:srgbClr val="000000"/>
-                </a:solidFill>
-              </a:rPr>
-            </a:r>
-          </a:p>
-          <a:p>
-            <a:pPr>
-              <a:spcAft>
-                <a:spcPts val="1000"/>
-              </a:spcAft>
-              <a:defRPr sz="1600">
-                <a:solidFill>
-                  <a:srgbClr val="000000"/>
-                </a:solidFill>
-              </a:defRPr>
-            </a:pPr>
-            <a:r>
-              <a:t>• Focus alignment message gives encouraging feedback about weekly volume progress.</a:t>
-              <a:rPr>
-                <a:solidFill>
-                  <a:srgbClr val="000000"/>
-                </a:solidFill>
-              </a:rPr>
+              <a:rPr>
+                <a:sz val="1600"/>
+                <a:solidFill>
+                  <a:srgbClr val="000000"/>
+                </a:solidFill>
+              </a:rPr>
+              <a:t>• Earn badges by completing workouts and challenges.</a:t>
+            </a:r>
+          </a:p>
+          <a:p>
+            <a:pPr>
+              <a:spcAft>
+                <a:spcPts val="1000"/>
+              </a:spcAft>
+              <a:defRPr sz="1600">
+                <a:solidFill>
+                  <a:srgbClr val="000000"/>
+                </a:solidFill>
+              </a:defRPr>
+            </a:pPr>
+            <a:r>
+              <a:rPr>
+                <a:sz val="1600"/>
+                <a:solidFill>
+                  <a:srgbClr val="000000"/>
+                </a:solidFill>
+              </a:rPr>
+              <a:t>• Six achievement categories to unlock and collect.</a:t>
+            </a:r>
+          </a:p>
+          <a:p>
+            <a:pPr>
+              <a:spcAft>
+                <a:spcPts val="1000"/>
+              </a:spcAft>
+              <a:defRPr sz="1600">
+                <a:solidFill>
+                  <a:srgbClr val="000000"/>
+                </a:solidFill>
+              </a:defRPr>
+            </a:pPr>
+            <a:r>
+              <a:rPr>
+                <a:sz val="1600"/>
+                <a:solidFill>
+                  <a:srgbClr val="000000"/>
+                </a:solidFill>
+              </a:rPr>
+              <a:t>• Badges track workout count, streaks, and volume.</a:t>
+            </a:r>
+          </a:p>
+          <a:p>
+            <a:pPr>
+              <a:spcAft>
+                <a:spcPts val="1000"/>
+              </a:spcAft>
+              <a:defRPr sz="1600">
+                <a:solidFill>
+                  <a:srgbClr val="000000"/>
+                </a:solidFill>
+              </a:defRPr>
+            </a:pPr>
+            <a:r>
+              <a:rPr>
+                <a:sz val="1600"/>
+                <a:solidFill>
+                  <a:srgbClr val="000000"/>
+                </a:solidFill>
+              </a:rPr>
+              <a:t>• Each badge can only be unlocked once.</a:t>
+            </a:r>
+          </a:p>
+          <a:p>
+            <a:pPr>
+              <a:spcAft>
+                <a:spcPts val="1000"/>
+              </a:spcAft>
+              <a:defRPr sz="1600">
+                <a:solidFill>
+                  <a:srgbClr val="000000"/>
+                </a:solidFill>
+              </a:defRPr>
+            </a:pPr>
+            <a:r>
+              <a:rPr>
+                <a:sz val="1600"/>
+                <a:solidFill>
+                  <a:srgbClr val="000000"/>
+                </a:solidFill>
+              </a:rPr>
+              <a:t>• Badges are color-coded: emerald, cyan, amber, and more.</a:t>
+            </a:r>
+          </a:p>
+          <a:p>
+            <a:pPr>
+              <a:spcAft>
+                <a:spcPts val="1000"/>
+              </a:spcAft>
+              <a:defRPr sz="1600">
+                <a:solidFill>
+                  <a:srgbClr val="000000"/>
+                </a:solidFill>
+              </a:defRPr>
+            </a:pPr>
+            <a:r>
+              <a:rPr>
+                <a:sz val="1600"/>
+                <a:solidFill>
+                  <a:srgbClr val="000000"/>
+                </a:solidFill>
+              </a:rPr>
+              <a:t>• Achievement page shows all badges and unlock status.</a:t>
             </a:r>
           </a:p>
         </p:txBody>
@@ -5942,7 +6271,7 @@
               </a:defRPr>
             </a:pPr>
             <a:r>
-              <a:t>Diet and Nutrition</a:t>
+              <a:t>Admin and Management</a:t>
               <a:rPr>
                 <a:solidFill>
                   <a:srgbClr val="000000"/>
@@ -5985,112 +6314,118 @@
               </a:defRPr>
             </a:pPr>
             <a:r>
-              <a:t>• Nutrition records log daily calories, protein, carbs, and fats with notes.</a:t>
-              <a:rPr>
-                <a:solidFill>
-                  <a:srgbClr val="000000"/>
-                </a:solidFill>
-              </a:rPr>
-            </a:r>
-          </a:p>
-          <a:p>
-            <a:pPr>
-              <a:spcAft>
-                <a:spcPts val="1000"/>
-              </a:spcAft>
-              <a:defRPr sz="1600">
-                <a:solidFill>
-                  <a:srgbClr val="000000"/>
-                </a:solidFill>
-              </a:defRPr>
-            </a:pPr>
-            <a:r>
-              <a:t>• BMR and TDEE calculator estimates daily energy needs based on user.</a:t>
-              <a:rPr>
-                <a:solidFill>
-                  <a:srgbClr val="000000"/>
-                </a:solidFill>
-              </a:rPr>
-            </a:r>
-          </a:p>
-          <a:p>
-            <a:pPr>
-              <a:spcAft>
-                <a:spcPts val="1000"/>
-              </a:spcAft>
-              <a:defRPr sz="1600">
-                <a:solidFill>
-                  <a:srgbClr val="000000"/>
-                </a:solidFill>
-              </a:defRPr>
-            </a:pPr>
-            <a:r>
-              <a:t>• Macro calculator splits calories into protein, carbs, and fats for meal.</a:t>
-              <a:rPr>
-                <a:solidFill>
-                  <a:srgbClr val="000000"/>
-                </a:solidFill>
-              </a:rPr>
-            </a:r>
-          </a:p>
-          <a:p>
-            <a:pPr>
-              <a:spcAft>
-                <a:spcPts val="1000"/>
-              </a:spcAft>
-              <a:defRPr sz="1600">
-                <a:solidFill>
-                  <a:srgbClr val="000000"/>
-                </a:solidFill>
-              </a:defRPr>
-            </a:pPr>
-            <a:r>
-              <a:t>• Affordable foods database lists budget-friendly ingredients with nutritional values.</a:t>
-              <a:rPr>
-                <a:solidFill>
-                  <a:srgbClr val="000000"/>
-                </a:solidFill>
-              </a:rPr>
-            </a:r>
-          </a:p>
-          <a:p>
-            <a:pPr>
-              <a:spcAft>
-                <a:spcPts val="1000"/>
-              </a:spcAft>
-              <a:defRPr sz="1600">
-                <a:solidFill>
-                  <a:srgbClr val="000000"/>
-                </a:solidFill>
-              </a:defRPr>
-            </a:pPr>
-            <a:r>
-              <a:t>• Budget meal presets provide complete meal plans with calculated macro totals.</a:t>
-              <a:rPr>
-                <a:solidFill>
-                  <a:srgbClr val="000000"/>
-                </a:solidFill>
-              </a:rPr>
-            </a:r>
-          </a:p>
-          <a:p>
-            <a:pPr>
-              <a:spcAft>
-                <a:spcPts val="1000"/>
-              </a:spcAft>
-              <a:defRPr sz="1600">
-                <a:solidFill>
-                  <a:srgbClr val="000000"/>
-                </a:solidFill>
-              </a:defRPr>
-            </a:pPr>
-            <a:r>
-              <a:t>• Meal suggestions generate weekly diet recommendations based on selected goals.</a:t>
-              <a:rPr>
-                <a:solidFill>
-                  <a:srgbClr val="000000"/>
-                </a:solidFill>
-              </a:rPr>
+              <a:rPr>
+                <a:sz val="1600"/>
+                <a:solidFill>
+                  <a:srgbClr val="000000"/>
+                </a:solidFill>
+              </a:rPr>
+              <a:t>• Admins manage users, exercises, products, and orders.</a:t>
+            </a:r>
+          </a:p>
+          <a:p>
+            <a:pPr>
+              <a:spcAft>
+                <a:spcPts val="1000"/>
+              </a:spcAft>
+              <a:defRPr sz="1600">
+                <a:solidFill>
+                  <a:srgbClr val="000000"/>
+                </a:solidFill>
+              </a:defRPr>
+            </a:pPr>
+            <a:r>
+              <a:rPr>
+                <a:sz val="1600"/>
+                <a:solidFill>
+                  <a:srgbClr val="000000"/>
+                </a:solidFill>
+              </a:rPr>
+              <a:t>• Add, edit, or remove exercises from the library.</a:t>
+            </a:r>
+          </a:p>
+          <a:p>
+            <a:pPr>
+              <a:spcAft>
+                <a:spcPts val="1000"/>
+              </a:spcAft>
+              <a:defRPr sz="1600">
+                <a:solidFill>
+                  <a:srgbClr val="000000"/>
+                </a:solidFill>
+              </a:defRPr>
+            </a:pPr>
+            <a:r>
+              <a:rPr>
+                <a:sz val="1600"/>
+                <a:solidFill>
+                  <a:srgbClr val="000000"/>
+                </a:solidFill>
+              </a:rPr>
+              <a:t>• Control user permissions and account settings.</a:t>
+            </a:r>
+          </a:p>
+          <a:p>
+            <a:pPr>
+              <a:spcAft>
+                <a:spcPts val="1000"/>
+              </a:spcAft>
+              <a:defRPr sz="1600">
+                <a:solidFill>
+                  <a:srgbClr val="000000"/>
+                </a:solidFill>
+              </a:defRPr>
+            </a:pPr>
+            <a:r>
+              <a:rPr>
+                <a:sz val="1600"/>
+                <a:solidFill>
+                  <a:srgbClr val="000000"/>
+                </a:solidFill>
+              </a:rPr>
+              <a:t>• Track store orders and process refunds.</a:t>
+            </a:r>
+          </a:p>
+          <a:p>
+            <a:pPr>
+              <a:spcAft>
+                <a:spcPts val="1000"/>
+              </a:spcAft>
+              <a:defRPr sz="1600">
+                <a:solidFill>
+                  <a:srgbClr val="000000"/>
+                </a:solidFill>
+              </a:defRPr>
+            </a:pPr>
+            <a:r>
+              <a:rPr>
+                <a:sz val="1600"/>
+                <a:solidFill>
+                  <a:srgbClr val="000000"/>
+                </a:solidFill>
+              </a:rPr>
+              <a:t>• Update inspiration quotes and fitness icon data.</a:t>
+            </a:r>
+          </a:p>
+          <a:p>
+            <a:pPr>
+              <a:spcAft>
+                <a:spcPts val="1000"/>
+              </a:spcAft>
+              <a:defRPr sz="1600">
+                <a:solidFill>
+                  <a:srgbClr val="000000"/>
+                </a:solidFill>
+              </a:defRPr>
+            </a:pPr>
+            <a:r>
+              <a:rPr>
+                <a:sz val="1600"/>
+                <a:solidFill>
+                  <a:srgbClr val="000000"/>
+                </a:solidFill>
+              </a:rPr>
+              <a:t>• Core settings let admins configure site options.</a:t>
             </a:r>
           </a:p>
         </p:txBody>
@@ -6150,7 +6485,7 @@
               </a:defRPr>
             </a:pPr>
             <a:r>
-              <a:t>Store and Shopping</a:t>
+              <a:t>Thank You</a:t>
               <a:rPr>
                 <a:solidFill>
                   <a:srgbClr val="000000"/>
@@ -6193,528 +6528,118 @@
               </a:defRPr>
             </a:pPr>
             <a:r>
-              <a:t>• Store has three categories: Outfits, Gear, and Supplements for fitness products.</a:t>
-              <a:rPr>
-                <a:solidFill>
-                  <a:srgbClr val="000000"/>
-                </a:solidFill>
-              </a:rPr>
-            </a:r>
-          </a:p>
-          <a:p>
-            <a:pPr>
-              <a:spcAft>
-                <a:spcPts val="1000"/>
-              </a:spcAft>
-              <a:defRPr sz="1600">
-                <a:solidFill>
-                  <a:srgbClr val="000000"/>
-                </a:solidFill>
-              </a:defRPr>
-            </a:pPr>
-            <a:r>
-              <a:t>• Twelve products include names, prices, descriptions, images, brands, and stock counts.</a:t>
-              <a:rPr>
-                <a:solidFill>
-                  <a:srgbClr val="000000"/>
-                </a:solidFill>
-              </a:rPr>
-            </a:r>
-          </a:p>
-          <a:p>
-            <a:pPr>
-              <a:spcAft>
-                <a:spcPts val="1000"/>
-              </a:spcAft>
-              <a:defRPr sz="1600">
-                <a:solidFill>
-                  <a:srgbClr val="000000"/>
-                </a:solidFill>
-              </a:defRPr>
-            </a:pPr>
-            <a:r>
-              <a:t>• Shopping cart supports both logged-in users and anonymous session-based guests.</a:t>
-              <a:rPr>
-                <a:solidFill>
-                  <a:srgbClr val="000000"/>
-                </a:solidFill>
-              </a:rPr>
-            </a:r>
-          </a:p>
-          <a:p>
-            <a:pPr>
-              <a:spcAft>
-                <a:spcPts val="1000"/>
-              </a:spcAft>
-              <a:defRPr sz="1600">
-                <a:solidFill>
-                  <a:srgbClr val="000000"/>
-                </a:solidFill>
-              </a:defRPr>
-            </a:pPr>
-            <a:r>
-              <a:t>• Cart calculates subtotal, shipping, tax, and total with free shipping over.</a:t>
-              <a:rPr>
-                <a:solidFill>
-                  <a:srgbClr val="000000"/>
-                </a:solidFill>
-              </a:rPr>
-            </a:r>
-          </a:p>
-          <a:p>
-            <a:pPr>
-              <a:spcAft>
-                <a:spcPts val="1000"/>
-              </a:spcAft>
-              <a:defRPr sz="1600">
-                <a:solidFill>
-                  <a:srgbClr val="000000"/>
-                </a:solidFill>
-              </a:defRPr>
-            </a:pPr>
-            <a:r>
-              <a:t>• Checkout saves orders with atomic stock reduction to prevent overselling safely.</a:t>
-              <a:rPr>
-                <a:solidFill>
-                  <a:srgbClr val="000000"/>
-                </a:solidFill>
-              </a:rPr>
-            </a:r>
-          </a:p>
-          <a:p>
-            <a:pPr>
-              <a:spcAft>
-                <a:spcPts val="1000"/>
-              </a:spcAft>
-              <a:defRPr sz="1600">
-                <a:solidFill>
-                  <a:srgbClr val="000000"/>
-                </a:solidFill>
-              </a:defRPr>
-            </a:pPr>
-            <a:r>
-              <a:t>• Order history tracks purchases with status, items, and delivery tracking information.</a:t>
-              <a:rPr>
-                <a:solidFill>
-                  <a:srgbClr val="000000"/>
-                </a:solidFill>
-              </a:rPr>
-            </a:r>
-          </a:p>
-        </p:txBody>
-      </p:sp>
-    </p:spTree>
-    <p:bg>
-      <p:bgPr>
-        <a:solidFill>
-          <a:srgbClr val="FFFFFF"/>
-        </a:solidFill>
-      </p:bgPr>
-    </p:bg>
-  </p:cSld>
-  <p:clrMapOvr>
-    <a:masterClrMapping/>
-  </p:clrMapOvr>
-</p:sld>
-</file>
-
-<file path=ppt/slides/slide18.xml><?xml version="1.0" encoding="utf-8"?>
-<p:sld xmlns:a="http://schemas.openxmlformats.org/drawingml/2006/main" xmlns:p="http://schemas.openxmlformats.org/presentationml/2006/main" xmlns:r="http://schemas.openxmlformats.org/officeDocument/2006/relationships">
-  <p:cSld>
-    <p:spTree>
-      <p:nvGrpSpPr>
-        <p:cNvPr id="1" name=""/>
-        <p:cNvGrpSpPr/>
-        <p:nvPr/>
-      </p:nvGrpSpPr>
-      <p:grpSpPr/>
-      <p:sp>
-        <p:nvSpPr>
-          <p:cNvPr id="2" name="TextBox 1"/>
-          <p:cNvSpPr txBox="1"/>
-          <p:nvPr/>
-        </p:nvSpPr>
-        <p:spPr>
-          <a:xfrm>
-            <a:off x="457200" y="228600"/>
-            <a:ext cx="10972800" cy="731520"/>
-          </a:xfrm>
-          <a:prstGeom prst="rect">
-            <a:avLst/>
-          </a:prstGeom>
-          <a:noFill/>
-        </p:spPr>
-        <p:txBody>
-          <a:bodyPr wrap="none">
-            <a:spAutoFit/>
-          </a:bodyPr>
-          <a:lstStyle/>
-          <a:p>
-            <a:pPr>
-              <a:defRPr sz="2800" b="1">
-                <a:solidFill>
-                  <a:srgbClr val="000000"/>
-                </a:solidFill>
-              </a:defRPr>
-            </a:pPr>
-            <a:r>
-              <a:t>Inspiration and Motivation</a:t>
-              <a:rPr>
-                <a:solidFill>
-                  <a:srgbClr val="000000"/>
-                </a:solidFill>
-              </a:rPr>
-            </a:r>
-          </a:p>
-        </p:txBody>
-      </p:sp>
-      <p:sp>
-        <p:nvSpPr>
-          <p:cNvPr id="3" name="TextBox 2"/>
-          <p:cNvSpPr txBox="1"/>
-          <p:nvPr/>
-        </p:nvSpPr>
-        <p:spPr>
-          <a:xfrm>
-            <a:off x="457200" y="1005840"/>
-            <a:ext cx="10972800" cy="5303520"/>
-          </a:xfrm>
-          <a:prstGeom prst="rect">
-            <a:avLst/>
-          </a:prstGeom>
-          <a:noFill/>
-        </p:spPr>
-        <p:txBody>
-          <a:bodyPr wrap="square">
-            <a:spAutoFit/>
-          </a:bodyPr>
-          <a:lstStyle/>
-          <a:p>
-            <a:pPr>
-              <a:spcAft>
-                <a:spcPts val="1000"/>
-              </a:spcAft>
-              <a:defRPr sz="1600">
-                <a:solidFill>
-                  <a:srgbClr val="000000"/>
-                </a:solidFill>
-              </a:defRPr>
-            </a:pPr>
-            <a:r>
-              <a:t>• Inspiration feed shows twenty-three fitness icons across six discipline categories.</a:t>
-              <a:rPr>
-                <a:solidFill>
-                  <a:srgbClr val="000000"/>
-                </a:solidFill>
-              </a:rPr>
-            </a:r>
-          </a:p>
-          <a:p>
-            <a:pPr>
-              <a:spcAft>
-                <a:spcPts val="1000"/>
-              </a:spcAft>
-              <a:defRPr sz="1600">
-                <a:solidFill>
-                  <a:srgbClr val="000000"/>
-                </a:solidFill>
-              </a:defRPr>
-            </a:pPr>
-            <a:r>
-              <a:t>• Each icon has biography, training tips, achievements, quotes, and YouTube videos.</a:t>
-              <a:rPr>
-                <a:solidFill>
-                  <a:srgbClr val="000000"/>
-                </a:solidFill>
-              </a:rPr>
-            </a:r>
-          </a:p>
-          <a:p>
-            <a:pPr>
-              <a:spcAft>
-                <a:spcPts val="1000"/>
-              </a:spcAft>
-              <a:defRPr sz="1600">
-                <a:solidFill>
-                  <a:srgbClr val="000000"/>
-                </a:solidFill>
-              </a:defRPr>
-            </a:pPr>
-            <a:r>
-              <a:t>• Motivation quotes rotate daily with eighty-eight seeded quotes from icons.</a:t>
-              <a:rPr>
-                <a:solidFill>
-                  <a:srgbClr val="000000"/>
-                </a:solidFill>
-              </a:rPr>
-            </a:r>
-          </a:p>
-          <a:p>
-            <a:pPr>
-              <a:spcAft>
-                <a:spcPts val="1000"/>
-              </a:spcAft>
-              <a:defRPr sz="1600">
-                <a:solidFill>
-                  <a:srgbClr val="000000"/>
-                </a:solidFill>
-              </a:defRPr>
-            </a:pPr>
-            <a:r>
-              <a:t>• Categories group icons by discipline like bodybuilding, athletics, and calisthenics.</a:t>
-              <a:rPr>
-                <a:solidFill>
-                  <a:srgbClr val="000000"/>
-                </a:solidFill>
-              </a:rPr>
-            </a:r>
-          </a:p>
-          <a:p>
-            <a:pPr>
-              <a:spcAft>
-                <a:spcPts val="1000"/>
-              </a:spcAft>
-              <a:defRPr sz="1600">
-                <a:solidFill>
-                  <a:srgbClr val="000000"/>
-                </a:solidFill>
-              </a:defRPr>
-            </a:pPr>
-            <a:r>
-              <a:t>• Quote wall lets users browse all quotes filtered by category and.</a:t>
-              <a:rPr>
-                <a:solidFill>
-                  <a:srgbClr val="000000"/>
-                </a:solidFill>
-              </a:rPr>
-            </a:r>
-          </a:p>
-          <a:p>
-            <a:pPr>
-              <a:spcAft>
-                <a:spcPts val="1000"/>
-              </a:spcAft>
-              <a:defRPr sz="1600">
-                <a:solidFill>
-                  <a:srgbClr val="000000"/>
-                </a:solidFill>
-              </a:defRPr>
-            </a:pPr>
-            <a:r>
-              <a:t>• Random quote API delivers fresh motivation via AJAX without page reloads.</a:t>
-              <a:rPr>
-                <a:solidFill>
-                  <a:srgbClr val="000000"/>
-                </a:solidFill>
-              </a:rPr>
-            </a:r>
-          </a:p>
-        </p:txBody>
-      </p:sp>
-    </p:spTree>
-    <p:bg>
-      <p:bgPr>
-        <a:solidFill>
-          <a:srgbClr val="FFFFFF"/>
-        </a:solidFill>
-      </p:bgPr>
-    </p:bg>
-  </p:cSld>
-  <p:clrMapOvr>
-    <a:masterClrMapping/>
-  </p:clrMapOvr>
-</p:sld>
-</file>
-
-<file path=ppt/slides/slide19.xml><?xml version="1.0" encoding="utf-8"?>
-<p:sld xmlns:a="http://schemas.openxmlformats.org/drawingml/2006/main" xmlns:p="http://schemas.openxmlformats.org/presentationml/2006/main" xmlns:r="http://schemas.openxmlformats.org/officeDocument/2006/relationships">
-  <p:cSld>
-    <p:spTree>
-      <p:nvGrpSpPr>
-        <p:cNvPr id="1" name=""/>
-        <p:cNvGrpSpPr/>
-        <p:nvPr/>
-      </p:nvGrpSpPr>
-      <p:grpSpPr/>
-      <p:sp>
-        <p:nvSpPr>
-          <p:cNvPr id="2" name="TextBox 1"/>
-          <p:cNvSpPr txBox="1"/>
-          <p:nvPr/>
-        </p:nvSpPr>
-        <p:spPr>
-          <a:xfrm>
-            <a:off x="457200" y="228600"/>
-            <a:ext cx="10972800" cy="731520"/>
-          </a:xfrm>
-          <a:prstGeom prst="rect">
-            <a:avLst/>
-          </a:prstGeom>
-          <a:noFill/>
-        </p:spPr>
-        <p:txBody>
-          <a:bodyPr wrap="none">
-            <a:spAutoFit/>
-          </a:bodyPr>
-          <a:lstStyle/>
-          <a:p>
-            <a:pPr>
-              <a:defRPr sz="2800" b="1">
-                <a:solidFill>
-                  <a:srgbClr val="000000"/>
-                </a:solidFill>
-              </a:defRPr>
-            </a:pPr>
-            <a:r>
-              <a:t>Social Features</a:t>
-              <a:rPr>
-                <a:solidFill>
-                  <a:srgbClr val="000000"/>
-                </a:solidFill>
-              </a:rPr>
-            </a:r>
-          </a:p>
-        </p:txBody>
-      </p:sp>
-      <p:sp>
-        <p:nvSpPr>
-          <p:cNvPr id="3" name="TextBox 2"/>
-          <p:cNvSpPr txBox="1"/>
-          <p:nvPr/>
-        </p:nvSpPr>
-        <p:spPr>
-          <a:xfrm>
-            <a:off x="457200" y="1005840"/>
-            <a:ext cx="10972800" cy="5303520"/>
-          </a:xfrm>
-          <a:prstGeom prst="rect">
-            <a:avLst/>
-          </a:prstGeom>
-          <a:noFill/>
-        </p:spPr>
-        <p:txBody>
-          <a:bodyPr wrap="square">
-            <a:spAutoFit/>
-          </a:bodyPr>
-          <a:lstStyle/>
-          <a:p>
-            <a:pPr>
-              <a:spcAft>
-                <a:spcPts val="1000"/>
-              </a:spcAft>
-              <a:defRPr sz="1600">
-                <a:solidFill>
-                  <a:srgbClr val="000000"/>
-                </a:solidFill>
-              </a:defRPr>
-            </a:pPr>
-            <a:r>
-              <a:t>• Connection model stores partner or rival requests with pending or accepted.</a:t>
-              <a:rPr>
-                <a:solidFill>
-                  <a:srgbClr val="000000"/>
-                </a:solidFill>
-              </a:rPr>
-            </a:r>
-          </a:p>
-          <a:p>
-            <a:pPr>
-              <a:spcAft>
-                <a:spcPts val="1000"/>
-              </a:spcAft>
-              <a:defRPr sz="1600">
-                <a:solidFill>
-                  <a:srgbClr val="000000"/>
-                </a:solidFill>
-              </a:defRPr>
-            </a:pPr>
-            <a:r>
-              <a:t>• Users send connection requests and accept or reject incoming requests easily.</a:t>
-              <a:rPr>
-                <a:solidFill>
-                  <a:srgbClr val="000000"/>
-                </a:solidFill>
-              </a:rPr>
-            </a:r>
-          </a:p>
-          <a:p>
-            <a:pPr>
-              <a:spcAft>
-                <a:spcPts val="1000"/>
-              </a:spcAft>
-              <a:defRPr sz="1600">
-                <a:solidFill>
-                  <a:srgbClr val="000000"/>
-                </a:solidFill>
-              </a:defRPr>
-            </a:pPr>
-            <a:r>
-              <a:t>• Private messaging allows direct text exchange between accepted connections only.</a:t>
-              <a:rPr>
-                <a:solidFill>
-                  <a:srgbClr val="000000"/>
-                </a:solidFill>
-              </a:rPr>
-            </a:r>
-          </a:p>
-          <a:p>
-            <a:pPr>
-              <a:spcAft>
-                <a:spcPts val="1000"/>
-              </a:spcAft>
-              <a:defRPr sz="1600">
-                <a:solidFill>
-                  <a:srgbClr val="000000"/>
-                </a:solidFill>
-              </a:defRPr>
-            </a:pPr>
-            <a:r>
-              <a:t>• Message model tracks sender, recipient, content, timestamp, and read status.</a:t>
-              <a:rPr>
-                <a:solidFill>
-                  <a:srgbClr val="000000"/>
-                </a:solidFill>
-              </a:rPr>
-            </a:r>
-          </a:p>
-          <a:p>
-            <a:pPr>
-              <a:spcAft>
-                <a:spcPts val="1000"/>
-              </a:spcAft>
-              <a:defRPr sz="1600">
-                <a:solidFill>
-                  <a:srgbClr val="000000"/>
-                </a:solidFill>
-              </a:defRPr>
-            </a:pPr>
-            <a:r>
-              <a:t>• Search users feature finds members by username or email to connect.</a:t>
-              <a:rPr>
-                <a:solidFill>
-                  <a:srgbClr val="000000"/>
-                </a:solidFill>
-              </a:rPr>
-            </a:r>
-          </a:p>
-          <a:p>
-            <a:pPr>
-              <a:spcAft>
-                <a:spcPts val="1000"/>
-              </a:spcAft>
-              <a:defRPr sz="1600">
-                <a:solidFill>
-                  <a:srgbClr val="000000"/>
-                </a:solidFill>
-              </a:defRPr>
-            </a:pPr>
-            <a:r>
-              <a:t>• Social hub displays partners, rivals, pending requests, and recent conversations.</a:t>
-              <a:rPr>
-                <a:solidFill>
-                  <a:srgbClr val="000000"/>
-                </a:solidFill>
-              </a:rPr>
+              <a:rPr>
+                <a:sz val="1600"/>
+                <a:solidFill>
+                  <a:srgbClr val="000000"/>
+                </a:solidFill>
+              </a:rPr>
+              <a:t>• Thank you for listening to our presentation today.</a:t>
+            </a:r>
+          </a:p>
+          <a:p>
+            <a:pPr>
+              <a:spcAft>
+                <a:spcPts val="1000"/>
+              </a:spcAft>
+              <a:defRPr sz="1600">
+                <a:solidFill>
+                  <a:srgbClr val="000000"/>
+                </a:solidFill>
+              </a:defRPr>
+            </a:pPr>
+            <a:r>
+              <a:rPr>
+                <a:sz val="1600"/>
+                <a:solidFill>
+                  <a:srgbClr val="000000"/>
+                </a:solidFill>
+              </a:rPr>
+              <a:t>• We hope you enjoyed learning about Fitness Hub.</a:t>
+            </a:r>
+          </a:p>
+          <a:p>
+            <a:pPr>
+              <a:spcAft>
+                <a:spcPts val="1000"/>
+              </a:spcAft>
+              <a:defRPr sz="1600">
+                <a:solidFill>
+                  <a:srgbClr val="000000"/>
+                </a:solidFill>
+              </a:defRPr>
+            </a:pPr>
+            <a:r>
+              <a:rPr>
+                <a:sz val="1600"/>
+                <a:solidFill>
+                  <a:srgbClr val="000000"/>
+                </a:solidFill>
+              </a:rPr>
+              <a:t>• Questions and discussion are welcome from the audience.</a:t>
+            </a:r>
+          </a:p>
+          <a:p>
+            <a:pPr>
+              <a:spcAft>
+                <a:spcPts val="1000"/>
+              </a:spcAft>
+              <a:defRPr sz="1600">
+                <a:solidFill>
+                  <a:srgbClr val="000000"/>
+                </a:solidFill>
+              </a:defRPr>
+            </a:pPr>
+            <a:r>
+              <a:rPr>
+                <a:sz val="1600"/>
+                <a:solidFill>
+                  <a:srgbClr val="000000"/>
+                </a:solidFill>
+              </a:rPr>
+              <a:t>• Your feedback helps us improve our platform further.</a:t>
+            </a:r>
+          </a:p>
+          <a:p>
+            <a:pPr>
+              <a:spcAft>
+                <a:spcPts val="1000"/>
+              </a:spcAft>
+              <a:defRPr sz="1600">
+                <a:solidFill>
+                  <a:srgbClr val="000000"/>
+                </a:solidFill>
+              </a:defRPr>
+            </a:pPr>
+            <a:r>
+              <a:rPr>
+                <a:sz val="1600"/>
+                <a:solidFill>
+                  <a:srgbClr val="000000"/>
+                </a:solidFill>
+              </a:rPr>
+              <a:t>• Proud to present our work from Shivapuri Secondary School.</a:t>
+            </a:r>
+          </a:p>
+          <a:p>
+            <a:pPr>
+              <a:spcAft>
+                <a:spcPts val="1000"/>
+              </a:spcAft>
+              <a:defRPr sz="1600">
+                <a:solidFill>
+                  <a:srgbClr val="000000"/>
+                </a:solidFill>
+              </a:defRPr>
+            </a:pPr>
+            <a:r>
+              <a:rPr>
+                <a:sz val="1600"/>
+                <a:solidFill>
+                  <a:srgbClr val="000000"/>
+                </a:solidFill>
+              </a:rPr>
+              <a:t>• Repo: github.com/FitHub-4/Fitness-Hub | Team Codex.</a:t>
             </a:r>
           </a:p>
         </p:txBody>
@@ -6817,736 +6742,118 @@
               </a:defRPr>
             </a:pPr>
             <a:r>
-              <a:t>• Django five point zero powers the backend with MTV architecture and.</a:t>
-              <a:rPr>
-                <a:solidFill>
-                  <a:srgbClr val="000000"/>
-                </a:solidFill>
-              </a:rPr>
-            </a:r>
-          </a:p>
-          <a:p>
-            <a:pPr>
-              <a:spcAft>
-                <a:spcPts val="1000"/>
-              </a:spcAft>
-              <a:defRPr sz="1600">
-                <a:solidFill>
-                  <a:srgbClr val="000000"/>
-                </a:solidFill>
-              </a:defRPr>
-            </a:pPr>
-            <a:r>
-              <a:t>• SQLite database stores all data with migrations for schema version control.</a:t>
-              <a:rPr>
-                <a:solidFill>
-                  <a:srgbClr val="000000"/>
-                </a:solidFill>
-              </a:rPr>
-            </a:r>
-          </a:p>
-          <a:p>
-            <a:pPr>
-              <a:spcAft>
-                <a:spcPts val="1000"/>
-              </a:spcAft>
-              <a:defRPr sz="1600">
-                <a:solidFill>
-                  <a:srgbClr val="000000"/>
-                </a:solidFill>
-              </a:defRPr>
-            </a:pPr>
-            <a:r>
-              <a:t>• HTML and CSS create responsive page layouts with mobile navigation support.</a:t>
-              <a:rPr>
-                <a:solidFill>
-                  <a:srgbClr val="000000"/>
-                </a:solidFill>
-              </a:rPr>
-            </a:r>
-          </a:p>
-          <a:p>
-            <a:pPr>
-              <a:spcAft>
-                <a:spcPts val="1000"/>
-              </a:spcAft>
-              <a:defRPr sz="1600">
-                <a:solidFill>
-                  <a:srgbClr val="000000"/>
-                </a:solidFill>
-              </a:defRPr>
-            </a:pPr>
-            <a:r>
-              <a:t>• JavaScript handles form validation, cart updates, and dynamic content loading.</a:t>
-              <a:rPr>
-                <a:solidFill>
-                  <a:srgbClr val="000000"/>
-                </a:solidFill>
-              </a:rPr>
-            </a:r>
-          </a:p>
-          <a:p>
-            <a:pPr>
-              <a:spcAft>
-                <a:spcPts val="1000"/>
-              </a:spcAft>
-              <a:defRPr sz="1600">
-                <a:solidFill>
-                  <a:srgbClr val="000000"/>
-                </a:solidFill>
-              </a:defRPr>
-            </a:pPr>
-            <a:r>
-              <a:t>• Groq API drives AI chatbot with Whisper transcription and Orpheus voice.</a:t>
-              <a:rPr>
-                <a:solidFill>
-                  <a:srgbClr val="000000"/>
-                </a:solidFill>
-              </a:rPr>
-            </a:r>
-          </a:p>
-          <a:p>
-            <a:pPr>
-              <a:spcAft>
-                <a:spcPts val="1000"/>
-              </a:spcAft>
-              <a:defRPr sz="1600">
-                <a:solidFill>
-                  <a:srgbClr val="000000"/>
-                </a:solidFill>
-              </a:defRPr>
-            </a:pPr>
-            <a:r>
-              <a:t>• Git and GitHub manage version control, branches, commits, and team collaboration.</a:t>
-              <a:rPr>
-                <a:solidFill>
-                  <a:srgbClr val="000000"/>
-                </a:solidFill>
-              </a:rPr>
-            </a:r>
-          </a:p>
-        </p:txBody>
-      </p:sp>
-    </p:spTree>
-    <p:bg>
-      <p:bgPr>
-        <a:solidFill>
-          <a:srgbClr val="FFFFFF"/>
-        </a:solidFill>
-      </p:bgPr>
-    </p:bg>
-  </p:cSld>
-  <p:clrMapOvr>
-    <a:masterClrMapping/>
-  </p:clrMapOvr>
-</p:sld>
-</file>
-
-<file path=ppt/slides/slide20.xml><?xml version="1.0" encoding="utf-8"?>
-<p:sld xmlns:a="http://schemas.openxmlformats.org/drawingml/2006/main" xmlns:p="http://schemas.openxmlformats.org/presentationml/2006/main" xmlns:r="http://schemas.openxmlformats.org/officeDocument/2006/relationships">
-  <p:cSld>
-    <p:spTree>
-      <p:nvGrpSpPr>
-        <p:cNvPr id="1" name=""/>
-        <p:cNvGrpSpPr/>
-        <p:nvPr/>
-      </p:nvGrpSpPr>
-      <p:grpSpPr/>
-      <p:sp>
-        <p:nvSpPr>
-          <p:cNvPr id="2" name="TextBox 1"/>
-          <p:cNvSpPr txBox="1"/>
-          <p:nvPr/>
-        </p:nvSpPr>
-        <p:spPr>
-          <a:xfrm>
-            <a:off x="457200" y="228600"/>
-            <a:ext cx="10972800" cy="731520"/>
-          </a:xfrm>
-          <a:prstGeom prst="rect">
-            <a:avLst/>
-          </a:prstGeom>
-          <a:noFill/>
-        </p:spPr>
-        <p:txBody>
-          <a:bodyPr wrap="none">
-            <a:spAutoFit/>
-          </a:bodyPr>
-          <a:lstStyle/>
-          <a:p>
-            <a:pPr>
-              <a:defRPr sz="2800" b="1">
-                <a:solidFill>
-                  <a:srgbClr val="000000"/>
-                </a:solidFill>
-              </a:defRPr>
-            </a:pPr>
-            <a:r>
-              <a:t>Achievements System</a:t>
-              <a:rPr>
-                <a:solidFill>
-                  <a:srgbClr val="000000"/>
-                </a:solidFill>
-              </a:rPr>
-            </a:r>
-          </a:p>
-        </p:txBody>
-      </p:sp>
-      <p:sp>
-        <p:nvSpPr>
-          <p:cNvPr id="3" name="TextBox 2"/>
-          <p:cNvSpPr txBox="1"/>
-          <p:nvPr/>
-        </p:nvSpPr>
-        <p:spPr>
-          <a:xfrm>
-            <a:off x="457200" y="1005840"/>
-            <a:ext cx="10972800" cy="5303520"/>
-          </a:xfrm>
-          <a:prstGeom prst="rect">
-            <a:avLst/>
-          </a:prstGeom>
-          <a:noFill/>
-        </p:spPr>
-        <p:txBody>
-          <a:bodyPr wrap="square">
-            <a:spAutoFit/>
-          </a:bodyPr>
-          <a:lstStyle/>
-          <a:p>
-            <a:pPr>
-              <a:spcAft>
-                <a:spcPts val="1000"/>
-              </a:spcAft>
-              <a:defRPr sz="1600">
-                <a:solidFill>
-                  <a:srgbClr val="000000"/>
-                </a:solidFill>
-              </a:defRPr>
-            </a:pPr>
-            <a:r>
-              <a:t>• Achievement model defines code, name, description, icon, category, and threshold values.</a:t>
-              <a:rPr>
-                <a:solidFill>
-                  <a:srgbClr val="000000"/>
-                </a:solidFill>
-              </a:rPr>
-            </a:r>
-          </a:p>
-          <a:p>
-            <a:pPr>
-              <a:spcAft>
-                <a:spcPts val="1000"/>
-              </a:spcAft>
-              <a:defRPr sz="1600">
-                <a:solidFill>
-                  <a:srgbClr val="000000"/>
-                </a:solidFill>
-              </a:defRPr>
-            </a:pPr>
-            <a:r>
-              <a:t>• Six categories include workout count, streak, volume, exercises, nutrition, and goals.</a:t>
-              <a:rPr>
-                <a:solidFill>
-                  <a:srgbClr val="000000"/>
-                </a:solidFill>
-              </a:rPr>
-            </a:r>
-          </a:p>
-          <a:p>
-            <a:pPr>
-              <a:spcAft>
-                <a:spcPts val="1000"/>
-              </a:spcAft>
-              <a:defRPr sz="1600">
-                <a:solidFill>
-                  <a:srgbClr val="000000"/>
-                </a:solidFill>
-              </a:defRPr>
-            </a:pPr>
-            <a:r>
-              <a:t>• UserAchievement links users to unlocked achievements with timestamps for tracking.</a:t>
-              <a:rPr>
-                <a:solidFill>
-                  <a:srgbClr val="000000"/>
-                </a:solidFill>
-              </a:rPr>
-            </a:r>
-          </a:p>
-          <a:p>
-            <a:pPr>
-              <a:spcAft>
-                <a:spcPts val="1000"/>
-              </a:spcAft>
-              <a:defRPr sz="1600">
-                <a:solidFill>
-                  <a:srgbClr val="000000"/>
-                </a:solidFill>
-              </a:defRPr>
-            </a:pPr>
-            <a:r>
-              <a:t>• Unique constraint ensures each achievement can be unlocked only once per.</a:t>
-              <a:rPr>
-                <a:solidFill>
-                  <a:srgbClr val="000000"/>
-                </a:solidFill>
-              </a:rPr>
-            </a:r>
-          </a:p>
-          <a:p>
-            <a:pPr>
-              <a:spcAft>
-                <a:spcPts val="1000"/>
-              </a:spcAft>
-              <a:defRPr sz="1600">
-                <a:solidFill>
-                  <a:srgbClr val="000000"/>
-                </a:solidFill>
-              </a:defRPr>
-            </a:pPr>
-            <a:r>
-              <a:t>• Badge colors use CSS classes like emerald, cyan, amber, violet, rose,.</a:t>
-              <a:rPr>
-                <a:solidFill>
-                  <a:srgbClr val="000000"/>
-                </a:solidFill>
-              </a:rPr>
-            </a:r>
-          </a:p>
-          <a:p>
-            <a:pPr>
-              <a:spcAft>
-                <a:spcPts val="1000"/>
-              </a:spcAft>
-              <a:defRPr sz="1600">
-                <a:solidFill>
-                  <a:srgbClr val="000000"/>
-                </a:solidFill>
-              </a:defRPr>
-            </a:pPr>
-            <a:r>
-              <a:t>• Achievement list page groups badges by category and shows unlock status.</a:t>
-              <a:rPr>
-                <a:solidFill>
-                  <a:srgbClr val="000000"/>
-                </a:solidFill>
-              </a:rPr>
-            </a:r>
-          </a:p>
-        </p:txBody>
-      </p:sp>
-    </p:spTree>
-    <p:bg>
-      <p:bgPr>
-        <a:solidFill>
-          <a:srgbClr val="FFFFFF"/>
-        </a:solidFill>
-      </p:bgPr>
-    </p:bg>
-  </p:cSld>
-  <p:clrMapOvr>
-    <a:masterClrMapping/>
-  </p:clrMapOvr>
-</p:sld>
-</file>
-
-<file path=ppt/slides/slide21.xml><?xml version="1.0" encoding="utf-8"?>
-<p:sld xmlns:a="http://schemas.openxmlformats.org/drawingml/2006/main" xmlns:p="http://schemas.openxmlformats.org/presentationml/2006/main" xmlns:r="http://schemas.openxmlformats.org/officeDocument/2006/relationships">
-  <p:cSld>
-    <p:spTree>
-      <p:nvGrpSpPr>
-        <p:cNvPr id="1" name=""/>
-        <p:cNvGrpSpPr/>
-        <p:nvPr/>
-      </p:nvGrpSpPr>
-      <p:grpSpPr/>
-      <p:sp>
-        <p:nvSpPr>
-          <p:cNvPr id="2" name="TextBox 1"/>
-          <p:cNvSpPr txBox="1"/>
-          <p:nvPr/>
-        </p:nvSpPr>
-        <p:spPr>
-          <a:xfrm>
-            <a:off x="457200" y="228600"/>
-            <a:ext cx="10972800" cy="731520"/>
-          </a:xfrm>
-          <a:prstGeom prst="rect">
-            <a:avLst/>
-          </a:prstGeom>
-          <a:noFill/>
-        </p:spPr>
-        <p:txBody>
-          <a:bodyPr wrap="none">
-            <a:spAutoFit/>
-          </a:bodyPr>
-          <a:lstStyle/>
-          <a:p>
-            <a:pPr>
-              <a:defRPr sz="2800" b="1">
-                <a:solidFill>
-                  <a:srgbClr val="000000"/>
-                </a:solidFill>
-              </a:defRPr>
-            </a:pPr>
-            <a:r>
-              <a:t>Admin and Management</a:t>
-              <a:rPr>
-                <a:solidFill>
-                  <a:srgbClr val="000000"/>
-                </a:solidFill>
-              </a:rPr>
-            </a:r>
-          </a:p>
-        </p:txBody>
-      </p:sp>
-      <p:sp>
-        <p:nvSpPr>
-          <p:cNvPr id="3" name="TextBox 2"/>
-          <p:cNvSpPr txBox="1"/>
-          <p:nvPr/>
-        </p:nvSpPr>
-        <p:spPr>
-          <a:xfrm>
-            <a:off x="457200" y="1005840"/>
-            <a:ext cx="10972800" cy="5303520"/>
-          </a:xfrm>
-          <a:prstGeom prst="rect">
-            <a:avLst/>
-          </a:prstGeom>
-          <a:noFill/>
-        </p:spPr>
-        <p:txBody>
-          <a:bodyPr wrap="square">
-            <a:spAutoFit/>
-          </a:bodyPr>
-          <a:lstStyle/>
-          <a:p>
-            <a:pPr>
-              <a:spcAft>
-                <a:spcPts val="1000"/>
-              </a:spcAft>
-              <a:defRPr sz="1600">
-                <a:solidFill>
-                  <a:srgbClr val="000000"/>
-                </a:solidFill>
-              </a:defRPr>
-            </a:pPr>
-            <a:r>
-              <a:t>• Django admin manages all app data including users, exercises, products, and.</a:t>
-              <a:rPr>
-                <a:solidFill>
-                  <a:srgbClr val="000000"/>
-                </a:solidFill>
-              </a:rPr>
-            </a:r>
-          </a:p>
-          <a:p>
-            <a:pPr>
-              <a:spcAft>
-                <a:spcPts val="1000"/>
-              </a:spcAft>
-              <a:defRPr sz="1600">
-                <a:solidFill>
-                  <a:srgbClr val="000000"/>
-                </a:solidFill>
-              </a:defRPr>
-            </a:pPr>
-            <a:r>
-              <a:t>• Exercise management allows adding, editing, and deleting workout library entries.</a:t>
-              <a:rPr>
-                <a:solidFill>
-                  <a:srgbClr val="000000"/>
-                </a:solidFill>
-              </a:rPr>
-            </a:r>
-          </a:p>
-          <a:p>
-            <a:pPr>
-              <a:spcAft>
-                <a:spcPts val="1000"/>
-              </a:spcAft>
-              <a:defRPr sz="1600">
-                <a:solidFill>
-                  <a:srgbClr val="000000"/>
-                </a:solidFill>
-              </a:defRPr>
-            </a:pPr>
-            <a:r>
-              <a:t>• User management controls permissions, account status, and profile modifications.</a:t>
-              <a:rPr>
-                <a:solidFill>
-                  <a:srgbClr val="000000"/>
-                </a:solidFill>
-              </a:rPr>
-            </a:r>
-          </a:p>
-          <a:p>
-            <a:pPr>
-              <a:spcAft>
-                <a:spcPts val="1000"/>
-              </a:spcAft>
-              <a:defRPr sz="1600">
-                <a:solidFill>
-                  <a:srgbClr val="000000"/>
-                </a:solidFill>
-              </a:defRPr>
-            </a:pPr>
-            <a:r>
-              <a:t>• Order management tracks store purchases and processes refunds when necessary.</a:t>
-              <a:rPr>
-                <a:solidFill>
-                  <a:srgbClr val="000000"/>
-                </a:solidFill>
-              </a:rPr>
-            </a:r>
-          </a:p>
-          <a:p>
-            <a:pPr>
-              <a:spcAft>
-                <a:spcPts val="1000"/>
-              </a:spcAft>
-              <a:defRPr sz="1600">
-                <a:solidFill>
-                  <a:srgbClr val="000000"/>
-                </a:solidFill>
-              </a:defRPr>
-            </a:pPr>
-            <a:r>
-              <a:t>• Content management updates inspiration quotes, images, and fitness icon data.</a:t>
-              <a:rPr>
-                <a:solidFill>
-                  <a:srgbClr val="000000"/>
-                </a:solidFill>
-              </a:rPr>
-            </a:r>
-          </a:p>
-          <a:p>
-            <a:pPr>
-              <a:spcAft>
-                <a:spcPts val="1000"/>
-              </a:spcAft>
-              <a:defRPr sz="1600">
-                <a:solidFill>
-                  <a:srgbClr val="000000"/>
-                </a:solidFill>
-              </a:defRPr>
-            </a:pPr>
-            <a:r>
-              <a:t>• Core app provides SiteSetting model for key-value configuration management.</a:t>
-              <a:rPr>
-                <a:solidFill>
-                  <a:srgbClr val="000000"/>
-                </a:solidFill>
-              </a:rPr>
-            </a:r>
-          </a:p>
-        </p:txBody>
-      </p:sp>
-    </p:spTree>
-    <p:bg>
-      <p:bgPr>
-        <a:solidFill>
-          <a:srgbClr val="FFFFFF"/>
-        </a:solidFill>
-      </p:bgPr>
-    </p:bg>
-  </p:cSld>
-  <p:clrMapOvr>
-    <a:masterClrMapping/>
-  </p:clrMapOvr>
-</p:sld>
-</file>
-
-<file path=ppt/slides/slide23.xml><?xml version="1.0" encoding="utf-8"?>
-<p:sld xmlns:a="http://schemas.openxmlformats.org/drawingml/2006/main" xmlns:p="http://schemas.openxmlformats.org/presentationml/2006/main" xmlns:r="http://schemas.openxmlformats.org/officeDocument/2006/relationships">
-  <p:cSld>
-    <p:spTree>
-      <p:nvGrpSpPr>
-        <p:cNvPr id="1" name=""/>
-        <p:cNvGrpSpPr/>
-        <p:nvPr/>
-      </p:nvGrpSpPr>
-      <p:grpSpPr/>
-      <p:sp>
-        <p:nvSpPr>
-          <p:cNvPr id="2" name="TextBox 1"/>
-          <p:cNvSpPr txBox="1"/>
-          <p:nvPr/>
-        </p:nvSpPr>
-        <p:spPr>
-          <a:xfrm>
-            <a:off x="457200" y="228600"/>
-            <a:ext cx="10972800" cy="731520"/>
-          </a:xfrm>
-          <a:prstGeom prst="rect">
-            <a:avLst/>
-          </a:prstGeom>
-          <a:noFill/>
-        </p:spPr>
-        <p:txBody>
-          <a:bodyPr wrap="none">
-            <a:spAutoFit/>
-          </a:bodyPr>
-          <a:lstStyle/>
-          <a:p>
-            <a:pPr>
-              <a:defRPr sz="2800" b="1">
-                <a:solidFill>
-                  <a:srgbClr val="000000"/>
-                </a:solidFill>
-              </a:defRPr>
-            </a:pPr>
-            <a:r>
-              <a:t>Thank You</a:t>
-              <a:rPr>
-                <a:solidFill>
-                  <a:srgbClr val="000000"/>
-                </a:solidFill>
-              </a:rPr>
-            </a:r>
-          </a:p>
-        </p:txBody>
-      </p:sp>
-      <p:sp>
-        <p:nvSpPr>
-          <p:cNvPr id="3" name="TextBox 2"/>
-          <p:cNvSpPr txBox="1"/>
-          <p:nvPr/>
-        </p:nvSpPr>
-        <p:spPr>
-          <a:xfrm>
-            <a:off x="457200" y="1005840"/>
-            <a:ext cx="10972800" cy="5303520"/>
-          </a:xfrm>
-          <a:prstGeom prst="rect">
-            <a:avLst/>
-          </a:prstGeom>
-          <a:noFill/>
-        </p:spPr>
-        <p:txBody>
-          <a:bodyPr wrap="square">
-            <a:spAutoFit/>
-          </a:bodyPr>
-          <a:lstStyle/>
-          <a:p>
-            <a:pPr>
-              <a:spcAft>
-                <a:spcPts val="1000"/>
-              </a:spcAft>
-              <a:defRPr sz="1600">
-                <a:solidFill>
-                  <a:srgbClr val="000000"/>
-                </a:solidFill>
-              </a:defRPr>
-            </a:pPr>
-            <a:r>
-              <a:t>• Thank you all for listening to our presentation about Fitness Hub.</a:t>
-              <a:rPr>
-                <a:solidFill>
-                  <a:srgbClr val="000000"/>
-                </a:solidFill>
-              </a:rPr>
-            </a:r>
-          </a:p>
-          <a:p>
-            <a:pPr>
-              <a:spcAft>
-                <a:spcPts val="1000"/>
-              </a:spcAft>
-              <a:defRPr sz="1600">
-                <a:solidFill>
-                  <a:srgbClr val="000000"/>
-                </a:solidFill>
-              </a:defRPr>
-            </a:pPr>
-            <a:r>
-              <a:t>• We hope you enjoyed learning about our project and team journey.</a:t>
-              <a:rPr>
-                <a:solidFill>
-                  <a:srgbClr val="000000"/>
-                </a:solidFill>
-              </a:rPr>
-            </a:r>
-          </a:p>
-          <a:p>
-            <a:pPr>
-              <a:spcAft>
-                <a:spcPts val="1000"/>
-              </a:spcAft>
-              <a:defRPr sz="1600">
-                <a:solidFill>
-                  <a:srgbClr val="000000"/>
-                </a:solidFill>
-              </a:defRPr>
-            </a:pPr>
-            <a:r>
-              <a:t>• Questions and discussions are welcome from the audience at this time.</a:t>
-              <a:rPr>
-                <a:solidFill>
-                  <a:srgbClr val="000000"/>
-                </a:solidFill>
-              </a:rPr>
-            </a:r>
-          </a:p>
-          <a:p>
-            <a:pPr>
-              <a:spcAft>
-                <a:spcPts val="1000"/>
-              </a:spcAft>
-              <a:defRPr sz="1600">
-                <a:solidFill>
-                  <a:srgbClr val="000000"/>
-                </a:solidFill>
-              </a:defRPr>
-            </a:pPr>
-            <a:r>
-              <a:t>• Your feedback and suggestions are valuable as we continue improving our.</a:t>
-              <a:rPr>
-                <a:solidFill>
-                  <a:srgbClr val="000000"/>
-                </a:solidFill>
-              </a:rPr>
-            </a:r>
-          </a:p>
-          <a:p>
-            <a:pPr>
-              <a:spcAft>
-                <a:spcPts val="1000"/>
-              </a:spcAft>
-              <a:defRPr sz="1600">
-                <a:solidFill>
-                  <a:srgbClr val="000000"/>
-                </a:solidFill>
-              </a:defRPr>
-            </a:pPr>
-            <a:r>
-              <a:t>• We are proud to share what we learned at Shivapuri Secondary.</a:t>
-              <a:rPr>
-                <a:solidFill>
-                  <a:srgbClr val="000000"/>
-                </a:solidFill>
-              </a:rPr>
-            </a:r>
-          </a:p>
-          <a:p>
-            <a:pPr>
-              <a:spcAft>
-                <a:spcPts val="1000"/>
-              </a:spcAft>
-              <a:defRPr sz="1600">
-                <a:solidFill>
-                  <a:srgbClr val="000000"/>
-                </a:solidFill>
-              </a:defRPr>
-            </a:pPr>
-            <a:r>
-              <a:t>• Repository: github.com/FitHub-4/Fitness-Hub | Team Codex wishes happy coding always.</a:t>
-              <a:rPr>
-                <a:solidFill>
-                  <a:srgbClr val="000000"/>
-                </a:solidFill>
-              </a:rPr>
+              <a:rPr>
+                <a:sz val="1600"/>
+                <a:solidFill>
+                  <a:srgbClr val="000000"/>
+                </a:solidFill>
+              </a:rPr>
+              <a:t>• Django 5.0 powers the backend with its MTV architecture.</a:t>
+            </a:r>
+          </a:p>
+          <a:p>
+            <a:pPr>
+              <a:spcAft>
+                <a:spcPts val="1000"/>
+              </a:spcAft>
+              <a:defRPr sz="1600">
+                <a:solidFill>
+                  <a:srgbClr val="000000"/>
+                </a:solidFill>
+              </a:defRPr>
+            </a:pPr>
+            <a:r>
+              <a:rPr>
+                <a:sz val="1600"/>
+                <a:solidFill>
+                  <a:srgbClr val="000000"/>
+                </a:solidFill>
+              </a:rPr>
+              <a:t>• SQLite database stores all user data with migration support.</a:t>
+            </a:r>
+          </a:p>
+          <a:p>
+            <a:pPr>
+              <a:spcAft>
+                <a:spcPts val="1000"/>
+              </a:spcAft>
+              <a:defRPr sz="1600">
+                <a:solidFill>
+                  <a:srgbClr val="000000"/>
+                </a:solidFill>
+              </a:defRPr>
+            </a:pPr>
+            <a:r>
+              <a:rPr>
+                <a:sz val="1600"/>
+                <a:solidFill>
+                  <a:srgbClr val="000000"/>
+                </a:solidFill>
+              </a:rPr>
+              <a:t>• Groq API with Llama model provides AI fitness coach responses.</a:t>
+            </a:r>
+          </a:p>
+          <a:p>
+            <a:pPr>
+              <a:spcAft>
+                <a:spcPts val="1000"/>
+              </a:spcAft>
+              <a:defRPr sz="1600">
+                <a:solidFill>
+                  <a:srgbClr val="000000"/>
+                </a:solidFill>
+              </a:defRPr>
+            </a:pPr>
+            <a:r>
+              <a:rPr>
+                <a:sz val="1600"/>
+                <a:solidFill>
+                  <a:srgbClr val="000000"/>
+                </a:solidFill>
+              </a:rPr>
+              <a:t>• Stripe API handles secure payment processing in the store.</a:t>
+            </a:r>
+          </a:p>
+          <a:p>
+            <a:pPr>
+              <a:spcAft>
+                <a:spcPts val="1000"/>
+              </a:spcAft>
+              <a:defRPr sz="1600">
+                <a:solidFill>
+                  <a:srgbClr val="000000"/>
+                </a:solidFill>
+              </a:defRPr>
+            </a:pPr>
+            <a:r>
+              <a:rPr>
+                <a:sz val="1600"/>
+                <a:solidFill>
+                  <a:srgbClr val="000000"/>
+                </a:solidFill>
+              </a:rPr>
+              <a:t>• HTML, CSS, and JavaScript create the responsive frontend UI.</a:t>
+            </a:r>
+          </a:p>
+          <a:p>
+            <a:pPr>
+              <a:spcAft>
+                <a:spcPts val="1000"/>
+              </a:spcAft>
+              <a:defRPr sz="1600">
+                <a:solidFill>
+                  <a:srgbClr val="000000"/>
+                </a:solidFill>
+              </a:defRPr>
+            </a:pPr>
+            <a:r>
+              <a:rPr>
+                <a:sz val="1600"/>
+                <a:solidFill>
+                  <a:srgbClr val="000000"/>
+                </a:solidFill>
+              </a:rPr>
+              <a:t>• Git and GitHub manage version control and team collaboration.</a:t>
             </a:r>
           </a:p>
         </p:txBody>
@@ -7649,112 +6956,118 @@
               </a:defRPr>
             </a:pPr>
             <a:r>
-              <a:t>• Fitness Hub is a Django web application designed to make fitness.</a:t>
-              <a:rPr>
-                <a:solidFill>
-                  <a:srgbClr val="000000"/>
-                </a:solidFill>
-              </a:rPr>
-            </a:r>
-          </a:p>
-          <a:p>
-            <a:pPr>
-              <a:spcAft>
-                <a:spcPts val="1000"/>
-              </a:spcAft>
-              <a:defRPr sz="1600">
-                <a:solidFill>
-                  <a:srgbClr val="000000"/>
-                </a:solidFill>
-              </a:defRPr>
-            </a:pPr>
-            <a:r>
-              <a:t>• It combines workout tracking, goal setting, diet logs, and social features.</a:t>
-              <a:rPr>
-                <a:solidFill>
-                  <a:srgbClr val="000000"/>
-                </a:solidFill>
-              </a:rPr>
-            </a:r>
-          </a:p>
-          <a:p>
-            <a:pPr>
-              <a:spcAft>
-                <a:spcPts val="1000"/>
-              </a:spcAft>
-              <a:defRPr sz="1600">
-                <a:solidFill>
-                  <a:srgbClr val="000000"/>
-                </a:solidFill>
-              </a:defRPr>
-            </a:pPr>
-            <a:r>
-              <a:t>• Users can exercise at home using the built-in library of guided.</a:t>
-              <a:rPr>
-                <a:solidFill>
-                  <a:srgbClr val="000000"/>
-                </a:solidFill>
-              </a:rPr>
-            </a:r>
-          </a:p>
-          <a:p>
-            <a:pPr>
-              <a:spcAft>
-                <a:spcPts val="1000"/>
-              </a:spcAft>
-              <a:defRPr sz="1600">
-                <a:solidFill>
-                  <a:srgbClr val="000000"/>
-                </a:solidFill>
-              </a:defRPr>
-            </a:pPr>
-            <a:r>
-              <a:t>• The platform motivates people with rewards, achievements, and progress tracking tools.</a:t>
-              <a:rPr>
-                <a:solidFill>
-                  <a:srgbClr val="000000"/>
-                </a:solidFill>
-              </a:rPr>
-            </a:r>
-          </a:p>
-          <a:p>
-            <a:pPr>
-              <a:spcAft>
-                <a:spcPts val="1000"/>
-              </a:spcAft>
-              <a:defRPr sz="1600">
-                <a:solidFill>
-                  <a:srgbClr val="000000"/>
-                </a:solidFill>
-              </a:defRPr>
-            </a:pPr>
-            <a:r>
-              <a:t>• It works like a personal fitness coach available anytime on your.</a:t>
-              <a:rPr>
-                <a:solidFill>
-                  <a:srgbClr val="000000"/>
-                </a:solidFill>
-              </a:rPr>
-            </a:r>
-          </a:p>
-          <a:p>
-            <a:pPr>
-              <a:spcAft>
-                <a:spcPts val="1000"/>
-              </a:spcAft>
-              <a:defRPr sz="1600">
-                <a:solidFill>
-                  <a:srgbClr val="000000"/>
-                </a:solidFill>
-              </a:defRPr>
-            </a:pPr>
-            <a:r>
-              <a:t>• Anyone can use it to build healthy habits and track their.</a:t>
-              <a:rPr>
-                <a:solidFill>
-                  <a:srgbClr val="000000"/>
-                </a:solidFill>
-              </a:rPr>
+              <a:rPr>
+                <a:sz val="1600"/>
+                <a:solidFill>
+                  <a:srgbClr val="000000"/>
+                </a:solidFill>
+              </a:rPr>
+              <a:t>• Fitness Hub is a Django web app for fitness tracking.</a:t>
+            </a:r>
+          </a:p>
+          <a:p>
+            <a:pPr>
+              <a:spcAft>
+                <a:spcPts val="1000"/>
+              </a:spcAft>
+              <a:defRPr sz="1600">
+                <a:solidFill>
+                  <a:srgbClr val="000000"/>
+                </a:solidFill>
+              </a:defRPr>
+            </a:pPr>
+            <a:r>
+              <a:rPr>
+                <a:sz val="1600"/>
+                <a:solidFill>
+                  <a:srgbClr val="000000"/>
+                </a:solidFill>
+              </a:rPr>
+              <a:t>• It combines workouts, goals, diet, and social features.</a:t>
+            </a:r>
+          </a:p>
+          <a:p>
+            <a:pPr>
+              <a:spcAft>
+                <a:spcPts val="1000"/>
+              </a:spcAft>
+              <a:defRPr sz="1600">
+                <a:solidFill>
+                  <a:srgbClr val="000000"/>
+                </a:solidFill>
+              </a:defRPr>
+            </a:pPr>
+            <a:r>
+              <a:rPr>
+                <a:sz val="1600"/>
+                <a:solidFill>
+                  <a:srgbClr val="000000"/>
+                </a:solidFill>
+              </a:rPr>
+              <a:t>• Users exercise at home with a built-in workout library.</a:t>
+            </a:r>
+          </a:p>
+          <a:p>
+            <a:pPr>
+              <a:spcAft>
+                <a:spcPts val="1000"/>
+              </a:spcAft>
+              <a:defRPr sz="1600">
+                <a:solidFill>
+                  <a:srgbClr val="000000"/>
+                </a:solidFill>
+              </a:defRPr>
+            </a:pPr>
+            <a:r>
+              <a:rPr>
+                <a:sz val="1600"/>
+                <a:solidFill>
+                  <a:srgbClr val="000000"/>
+                </a:solidFill>
+              </a:rPr>
+              <a:t>• The platform motivates with rewards and achievements.</a:t>
+            </a:r>
+          </a:p>
+          <a:p>
+            <a:pPr>
+              <a:spcAft>
+                <a:spcPts val="1000"/>
+              </a:spcAft>
+              <a:defRPr sz="1600">
+                <a:solidFill>
+                  <a:srgbClr val="000000"/>
+                </a:solidFill>
+              </a:defRPr>
+            </a:pPr>
+            <a:r>
+              <a:rPr>
+                <a:sz val="1600"/>
+                <a:solidFill>
+                  <a:srgbClr val="000000"/>
+                </a:solidFill>
+              </a:rPr>
+              <a:t>• It works like a personal coach in your browser.</a:t>
+            </a:r>
+          </a:p>
+          <a:p>
+            <a:pPr>
+              <a:spcAft>
+                <a:spcPts val="1000"/>
+              </a:spcAft>
+              <a:defRPr sz="1600">
+                <a:solidFill>
+                  <a:srgbClr val="000000"/>
+                </a:solidFill>
+              </a:defRPr>
+            </a:pPr>
+            <a:r>
+              <a:rPr>
+                <a:sz val="1600"/>
+                <a:solidFill>
+                  <a:srgbClr val="000000"/>
+                </a:solidFill>
+              </a:rPr>
+              <a:t>• Anyone can build healthy habits and track progress.</a:t>
             </a:r>
           </a:p>
         </p:txBody>
@@ -7857,112 +7170,118 @@
               </a:defRPr>
             </a:pPr>
             <a:r>
-              <a:t>• Create a user-friendly platform that makes fitness tracking easy for beginners.</a:t>
-              <a:rPr>
-                <a:solidFill>
-                  <a:srgbClr val="000000"/>
-                </a:solidFill>
-              </a:rPr>
-            </a:r>
-          </a:p>
-          <a:p>
-            <a:pPr>
-              <a:spcAft>
-                <a:spcPts val="1000"/>
-              </a:spcAft>
-              <a:defRPr sz="1600">
-                <a:solidFill>
-                  <a:srgbClr val="000000"/>
-                </a:solidFill>
-              </a:defRPr>
-            </a:pPr>
-            <a:r>
-              <a:t>• Integrate modern web technologies like Django and AI into a real.</a:t>
-              <a:rPr>
-                <a:solidFill>
-                  <a:srgbClr val="000000"/>
-                </a:solidFill>
-              </a:rPr>
-            </a:r>
-          </a:p>
-          <a:p>
-            <a:pPr>
-              <a:spcAft>
-                <a:spcPts val="1000"/>
-              </a:spcAft>
-              <a:defRPr sz="1600">
-                <a:solidFill>
-                  <a:srgbClr val="000000"/>
-                </a:solidFill>
-              </a:defRPr>
-            </a:pPr>
-            <a:r>
-              <a:t>• Help users set realistic fitness goals and track their progress over.</a:t>
-              <a:rPr>
-                <a:solidFill>
-                  <a:srgbClr val="000000"/>
-                </a:solidFill>
-              </a:rPr>
-            </a:r>
-          </a:p>
-          <a:p>
-            <a:pPr>
-              <a:spcAft>
-                <a:spcPts val="1000"/>
-              </a:spcAft>
-              <a:defRPr sz="1600">
-                <a:solidFill>
-                  <a:srgbClr val="000000"/>
-                </a:solidFill>
-              </a:defRPr>
-            </a:pPr>
-            <a:r>
-              <a:t>• Provide personalized workout and diet recommendations based on user needs.</a:t>
-              <a:rPr>
-                <a:solidFill>
-                  <a:srgbClr val="000000"/>
-                </a:solidFill>
-              </a:rPr>
-            </a:r>
-          </a:p>
-          <a:p>
-            <a:pPr>
-              <a:spcAft>
-                <a:spcPts val="1000"/>
-              </a:spcAft>
-              <a:defRPr sz="1600">
-                <a:solidFill>
-                  <a:srgbClr val="000000"/>
-                </a:solidFill>
-              </a:defRPr>
-            </a:pPr>
-            <a:r>
-              <a:t>• Build teamwork and problem-solving skills through practical project development.</a:t>
-              <a:rPr>
-                <a:solidFill>
-                  <a:srgbClr val="000000"/>
-                </a:solidFill>
-              </a:rPr>
-            </a:r>
-          </a:p>
-          <a:p>
-            <a:pPr>
-              <a:spcAft>
-                <a:spcPts val="1000"/>
-              </a:spcAft>
-              <a:defRPr sz="1600">
-                <a:solidFill>
-                  <a:srgbClr val="000000"/>
-                </a:solidFill>
-              </a:defRPr>
-            </a:pPr>
-            <a:r>
-              <a:t>• Demonstrate how classroom knowledge can create useful, real-world software solutions.</a:t>
-              <a:rPr>
-                <a:solidFill>
-                  <a:srgbClr val="000000"/>
-                </a:solidFill>
-              </a:rPr>
+              <a:rPr>
+                <a:sz val="1600"/>
+                <a:solidFill>
+                  <a:srgbClr val="000000"/>
+                </a:solidFill>
+              </a:rPr>
+              <a:t>• Create a simple fitness tracking platform for beginners.</a:t>
+            </a:r>
+          </a:p>
+          <a:p>
+            <a:pPr>
+              <a:spcAft>
+                <a:spcPts val="1000"/>
+              </a:spcAft>
+              <a:defRPr sz="1600">
+                <a:solidFill>
+                  <a:srgbClr val="000000"/>
+                </a:solidFill>
+              </a:defRPr>
+            </a:pPr>
+            <a:r>
+              <a:rPr>
+                <a:sz val="1600"/>
+                <a:solidFill>
+                  <a:srgbClr val="000000"/>
+                </a:solidFill>
+              </a:rPr>
+              <a:t>• Use Django and AI to build a real web application.</a:t>
+            </a:r>
+          </a:p>
+          <a:p>
+            <a:pPr>
+              <a:spcAft>
+                <a:spcPts val="1000"/>
+              </a:spcAft>
+              <a:defRPr sz="1600">
+                <a:solidFill>
+                  <a:srgbClr val="000000"/>
+                </a:solidFill>
+              </a:defRPr>
+            </a:pPr>
+            <a:r>
+              <a:rPr>
+                <a:sz val="1600"/>
+                <a:solidFill>
+                  <a:srgbClr val="000000"/>
+                </a:solidFill>
+              </a:rPr>
+              <a:t>• Help users set fitness goals and track progress.</a:t>
+            </a:r>
+          </a:p>
+          <a:p>
+            <a:pPr>
+              <a:spcAft>
+                <a:spcPts val="1000"/>
+              </a:spcAft>
+              <a:defRPr sz="1600">
+                <a:solidFill>
+                  <a:srgbClr val="000000"/>
+                </a:solidFill>
+              </a:defRPr>
+            </a:pPr>
+            <a:r>
+              <a:rPr>
+                <a:sz val="1600"/>
+                <a:solidFill>
+                  <a:srgbClr val="000000"/>
+                </a:solidFill>
+              </a:rPr>
+              <a:t>• Provide personalized workout and diet recommendations.</a:t>
+            </a:r>
+          </a:p>
+          <a:p>
+            <a:pPr>
+              <a:spcAft>
+                <a:spcPts val="1000"/>
+              </a:spcAft>
+              <a:defRPr sz="1600">
+                <a:solidFill>
+                  <a:srgbClr val="000000"/>
+                </a:solidFill>
+              </a:defRPr>
+            </a:pPr>
+            <a:r>
+              <a:rPr>
+                <a:sz val="1600"/>
+                <a:solidFill>
+                  <a:srgbClr val="000000"/>
+                </a:solidFill>
+              </a:rPr>
+              <a:t>• Build teamwork skills through practical development.</a:t>
+            </a:r>
+          </a:p>
+          <a:p>
+            <a:pPr>
+              <a:spcAft>
+                <a:spcPts val="1000"/>
+              </a:spcAft>
+              <a:defRPr sz="1600">
+                <a:solidFill>
+                  <a:srgbClr val="000000"/>
+                </a:solidFill>
+              </a:defRPr>
+            </a:pPr>
+            <a:r>
+              <a:rPr>
+                <a:sz val="1600"/>
+                <a:solidFill>
+                  <a:srgbClr val="000000"/>
+                </a:solidFill>
+              </a:rPr>
+              <a:t>• Turn classroom knowledge into a working software product.</a:t>
             </a:r>
           </a:p>
         </p:txBody>
@@ -8065,112 +7384,974 @@
               </a:defRPr>
             </a:pPr>
             <a:r>
-              <a:t>• Django follows the Model-Template-View pattern for web application development.</a:t>
-              <a:rPr>
-                <a:solidFill>
-                  <a:srgbClr val="000000"/>
-                </a:solidFill>
-              </a:rPr>
-            </a:r>
-          </a:p>
-          <a:p>
-            <a:pPr>
-              <a:spcAft>
-                <a:spcPts val="1000"/>
-              </a:spcAft>
-              <a:defRPr sz="1600">
-                <a:solidFill>
-                  <a:srgbClr val="000000"/>
-                </a:solidFill>
-              </a:defRPr>
-            </a:pPr>
-            <a:r>
-              <a:t>• Models define database structure using Python classes instead of SQL queries.</a:t>
-              <a:rPr>
-                <a:solidFill>
-                  <a:srgbClr val="000000"/>
-                </a:solidFill>
-              </a:rPr>
-            </a:r>
-          </a:p>
-          <a:p>
-            <a:pPr>
-              <a:spcAft>
-                <a:spcPts val="1000"/>
-              </a:spcAft>
-              <a:defRPr sz="1600">
-                <a:solidFill>
-                  <a:srgbClr val="000000"/>
-                </a:solidFill>
-              </a:defRPr>
-            </a:pPr>
-            <a:r>
-              <a:t>• Views handle user requests, process data, and return appropriate responses.</a:t>
-              <a:rPr>
-                <a:solidFill>
-                  <a:srgbClr val="000000"/>
-                </a:solidFill>
-              </a:rPr>
-            </a:r>
-          </a:p>
-          <a:p>
-            <a:pPr>
-              <a:spcAft>
-                <a:spcPts val="1000"/>
-              </a:spcAft>
-              <a:defRPr sz="1600">
-                <a:solidFill>
-                  <a:srgbClr val="000000"/>
-                </a:solidFill>
-              </a:defRPr>
-            </a:pPr>
-            <a:r>
-              <a:t>• Templates generate dynamic HTML pages with embedded Python variables.</a:t>
-              <a:rPr>
-                <a:solidFill>
-                  <a:srgbClr val="000000"/>
-                </a:solidFill>
-              </a:rPr>
-            </a:r>
-          </a:p>
-          <a:p>
-            <a:pPr>
-              <a:spcAft>
-                <a:spcPts val="1000"/>
-              </a:spcAft>
-              <a:defRPr sz="1600">
-                <a:solidFill>
-                  <a:srgbClr val="000000"/>
-                </a:solidFill>
-              </a:defRPr>
-            </a:pPr>
-            <a:r>
-              <a:t>• URLs map web addresses to specific view functions for navigation.</a:t>
-              <a:rPr>
-                <a:solidFill>
-                  <a:srgbClr val="000000"/>
-                </a:solidFill>
-              </a:rPr>
-            </a:r>
-          </a:p>
-          <a:p>
-            <a:pPr>
-              <a:spcAft>
-                <a:spcPts val="1000"/>
-              </a:spcAft>
-              <a:defRPr sz="1600">
-                <a:solidFill>
-                  <a:srgbClr val="000000"/>
-                </a:solidFill>
-              </a:defRPr>
-            </a:pPr>
-            <a:r>
-              <a:t>• This separation keeps code organized, reusable, and easy to maintain throughout.</a:t>
-              <a:rPr>
-                <a:solidFill>
-                  <a:srgbClr val="000000"/>
-                </a:solidFill>
-              </a:rPr>
+              <a:rPr>
+                <a:sz val="1600"/>
+                <a:solidFill>
+                  <a:srgbClr val="000000"/>
+                </a:solidFill>
+              </a:rPr>
+              <a:t>• Django uses the Model-Template-View pattern for organization.</a:t>
+            </a:r>
+          </a:p>
+          <a:p>
+            <a:pPr>
+              <a:spcAft>
+                <a:spcPts val="1000"/>
+              </a:spcAft>
+              <a:defRPr sz="1600">
+                <a:solidFill>
+                  <a:srgbClr val="000000"/>
+                </a:solidFill>
+              </a:defRPr>
+            </a:pPr>
+            <a:r>
+              <a:rPr>
+                <a:sz val="1600"/>
+                <a:solidFill>
+                  <a:srgbClr val="000000"/>
+                </a:solidFill>
+              </a:rPr>
+              <a:t>• Models define the database structure using Python classes.</a:t>
+            </a:r>
+          </a:p>
+          <a:p>
+            <a:pPr>
+              <a:spcAft>
+                <a:spcPts val="1000"/>
+              </a:spcAft>
+              <a:defRPr sz="1600">
+                <a:solidFill>
+                  <a:srgbClr val="000000"/>
+                </a:solidFill>
+              </a:defRPr>
+            </a:pPr>
+            <a:r>
+              <a:rPr>
+                <a:sz val="1600"/>
+                <a:solidFill>
+                  <a:srgbClr val="000000"/>
+                </a:solidFill>
+              </a:rPr>
+              <a:t>• Views handle user requests and process data logic.</a:t>
+            </a:r>
+          </a:p>
+          <a:p>
+            <a:pPr>
+              <a:spcAft>
+                <a:spcPts val="1000"/>
+              </a:spcAft>
+              <a:defRPr sz="1600">
+                <a:solidFill>
+                  <a:srgbClr val="000000"/>
+                </a:solidFill>
+              </a:defRPr>
+            </a:pPr>
+            <a:r>
+              <a:rPr>
+                <a:sz val="1600"/>
+                <a:solidFill>
+                  <a:srgbClr val="000000"/>
+                </a:solidFill>
+              </a:rPr>
+              <a:t>• Templates create HTML pages with dynamic content.</a:t>
+            </a:r>
+          </a:p>
+          <a:p>
+            <a:pPr>
+              <a:spcAft>
+                <a:spcPts val="1000"/>
+              </a:spcAft>
+              <a:defRPr sz="1600">
+                <a:solidFill>
+                  <a:srgbClr val="000000"/>
+                </a:solidFill>
+              </a:defRPr>
+            </a:pPr>
+            <a:r>
+              <a:rPr>
+                <a:sz val="1600"/>
+                <a:solidFill>
+                  <a:srgbClr val="000000"/>
+                </a:solidFill>
+              </a:rPr>
+              <a:t>• URLs connect web addresses to specific view functions.</a:t>
+            </a:r>
+          </a:p>
+          <a:p>
+            <a:pPr>
+              <a:spcAft>
+                <a:spcPts val="1000"/>
+              </a:spcAft>
+              <a:defRPr sz="1600">
+                <a:solidFill>
+                  <a:srgbClr val="000000"/>
+                </a:solidFill>
+              </a:defRPr>
+            </a:pPr>
+            <a:r>
+              <a:rPr>
+                <a:sz val="1600"/>
+                <a:solidFill>
+                  <a:srgbClr val="000000"/>
+                </a:solidFill>
+              </a:rPr>
+              <a:t>• This keeps code clean, reusable, and easy to maintain.</a:t>
+            </a:r>
+          </a:p>
+        </p:txBody>
+      </p:sp>
+    </p:spTree>
+    <p:bg>
+      <p:bgPr>
+        <a:solidFill>
+          <a:srgbClr val="FFFFFF"/>
+        </a:solidFill>
+      </p:bgPr>
+    </p:bg>
+  </p:cSld>
+  <p:clrMapOvr>
+    <a:masterClrMapping/>
+  </p:clrMapOvr>
+</p:sld>
+</file>
+
+<file path=ppt/slides/slide6.xml><?xml version="1.0" encoding="utf-8"?>
+<p:sld xmlns:a="http://schemas.openxmlformats.org/drawingml/2006/main" xmlns:p="http://schemas.openxmlformats.org/presentationml/2006/main" xmlns:r="http://schemas.openxmlformats.org/officeDocument/2006/relationships">
+  <p:cSld>
+    <p:spTree>
+      <p:nvGrpSpPr>
+        <p:cNvPr id="1" name=""/>
+        <p:cNvGrpSpPr/>
+        <p:nvPr/>
+      </p:nvGrpSpPr>
+      <p:grpSpPr/>
+      <p:sp>
+        <p:nvSpPr>
+          <p:cNvPr id="2" name="TextBox 1"/>
+          <p:cNvSpPr txBox="1"/>
+          <p:nvPr/>
+        </p:nvSpPr>
+        <p:spPr>
+          <a:xfrm>
+            <a:off x="457200" y="228600"/>
+            <a:ext cx="10972800" cy="731520"/>
+          </a:xfrm>
+          <a:prstGeom prst="rect">
+            <a:avLst/>
+          </a:prstGeom>
+          <a:noFill/>
+        </p:spPr>
+        <p:txBody>
+          <a:bodyPr wrap="none">
+            <a:spAutoFit/>
+          </a:bodyPr>
+          <a:lstStyle/>
+          <a:p>
+            <a:pPr>
+              <a:defRPr sz="2800" b="1">
+                <a:solidFill>
+                  <a:srgbClr val="000000"/>
+                </a:solidFill>
+              </a:defRPr>
+            </a:pPr>
+            <a:r>
+              <a:t>Login and Signup</a:t>
+              <a:rPr>
+                <a:solidFill>
+                  <a:srgbClr val="000000"/>
+                </a:solidFill>
+              </a:rPr>
+            </a:r>
+          </a:p>
+        </p:txBody>
+      </p:sp>
+      <p:sp>
+        <p:nvSpPr>
+          <p:cNvPr id="3" name="TextBox 2"/>
+          <p:cNvSpPr txBox="1"/>
+          <p:nvPr/>
+        </p:nvSpPr>
+        <p:spPr>
+          <a:xfrm>
+            <a:off x="457200" y="1005840"/>
+            <a:ext cx="10972800" cy="5303520"/>
+          </a:xfrm>
+          <a:prstGeom prst="rect">
+            <a:avLst/>
+          </a:prstGeom>
+          <a:noFill/>
+        </p:spPr>
+        <p:txBody>
+          <a:bodyPr wrap="square">
+            <a:spAutoFit/>
+          </a:bodyPr>
+          <a:lstStyle/>
+          <a:p>
+            <a:pPr>
+              <a:spcAft>
+                <a:spcPts val="1000"/>
+              </a:spcAft>
+              <a:defRPr sz="1600">
+                <a:solidFill>
+                  <a:srgbClr val="000000"/>
+                </a:solidFill>
+              </a:defRPr>
+            </a:pPr>
+            <a:r>
+              <a:rPr>
+                <a:sz val="1600"/>
+                <a:solidFill>
+                  <a:srgbClr val="000000"/>
+                </a:solidFill>
+              </a:rPr>
+              <a:t>• Users register with username, email, password, and body stats.</a:t>
+            </a:r>
+          </a:p>
+          <a:p>
+            <a:pPr>
+              <a:spcAft>
+                <a:spcPts val="1000"/>
+              </a:spcAft>
+              <a:defRPr sz="1600">
+                <a:solidFill>
+                  <a:srgbClr val="000000"/>
+                </a:solidFill>
+              </a:defRPr>
+            </a:pPr>
+            <a:r>
+              <a:rPr>
+                <a:sz val="1600"/>
+                <a:solidFill>
+                  <a:srgbClr val="000000"/>
+                </a:solidFill>
+              </a:rPr>
+              <a:t>• A Profile is automatically created for each new user.</a:t>
+            </a:r>
+          </a:p>
+          <a:p>
+            <a:pPr>
+              <a:spcAft>
+                <a:spcPts val="1000"/>
+              </a:spcAft>
+              <a:defRPr sz="1600">
+                <a:solidFill>
+                  <a:srgbClr val="000000"/>
+                </a:solidFill>
+              </a:defRPr>
+            </a:pPr>
+            <a:r>
+              <a:rPr>
+                <a:sz val="1600"/>
+                <a:solidFill>
+                  <a:srgbClr val="000000"/>
+                </a:solidFill>
+              </a:rPr>
+              <a:t>• Returning users log in with username and password.</a:t>
+            </a:r>
+          </a:p>
+          <a:p>
+            <a:pPr>
+              <a:spcAft>
+                <a:spcPts val="1000"/>
+              </a:spcAft>
+              <a:defRPr sz="1600">
+                <a:solidFill>
+                  <a:srgbClr val="000000"/>
+                </a:solidFill>
+              </a:defRPr>
+            </a:pPr>
+            <a:r>
+              <a:rPr>
+                <a:sz val="1600"/>
+                <a:solidFill>
+                  <a:srgbClr val="000000"/>
+                </a:solidFill>
+              </a:rPr>
+              <a:t>• Login page shows motivational quotes for inspiration.</a:t>
+            </a:r>
+          </a:p>
+          <a:p>
+            <a:pPr>
+              <a:spcAft>
+                <a:spcPts val="1000"/>
+              </a:spcAft>
+              <a:defRPr sz="1600">
+                <a:solidFill>
+                  <a:srgbClr val="000000"/>
+                </a:solidFill>
+              </a:defRPr>
+            </a:pPr>
+            <a:r>
+              <a:rPr>
+                <a:sz val="1600"/>
+                <a:solidFill>
+                  <a:srgbClr val="000000"/>
+                </a:solidFill>
+              </a:rPr>
+              <a:t>• Password reset helps users recover forgotten accounts.</a:t>
+            </a:r>
+          </a:p>
+          <a:p>
+            <a:pPr>
+              <a:spcAft>
+                <a:spcPts val="1000"/>
+              </a:spcAft>
+              <a:defRPr sz="1600">
+                <a:solidFill>
+                  <a:srgbClr val="000000"/>
+                </a:solidFill>
+              </a:defRPr>
+            </a:pPr>
+            <a:r>
+              <a:rPr>
+                <a:sz val="1600"/>
+                <a:solidFill>
+                  <a:srgbClr val="000000"/>
+                </a:solidFill>
+              </a:rPr>
+              <a:t>• All authentication uses Django's built-in secure forms.</a:t>
+            </a:r>
+          </a:p>
+        </p:txBody>
+      </p:sp>
+    </p:spTree>
+    <p:bg>
+      <p:bgPr>
+        <a:solidFill>
+          <a:srgbClr val="FFFFFF"/>
+        </a:solidFill>
+      </p:bgPr>
+    </p:bg>
+  </p:cSld>
+  <p:clrMapOvr>
+    <a:masterClrMapping/>
+  </p:clrMapOvr>
+</p:sld>
+</file>
+
+<file path=ppt/slides/slide7.xml><?xml version="1.0" encoding="utf-8"?>
+<p:sld xmlns:a="http://schemas.openxmlformats.org/drawingml/2006/main" xmlns:p="http://schemas.openxmlformats.org/presentationml/2006/main" xmlns:r="http://schemas.openxmlformats.org/officeDocument/2006/relationships">
+  <p:cSld>
+    <p:spTree>
+      <p:nvGrpSpPr>
+        <p:cNvPr id="1" name=""/>
+        <p:cNvGrpSpPr/>
+        <p:nvPr/>
+      </p:nvGrpSpPr>
+      <p:grpSpPr/>
+      <p:sp>
+        <p:nvSpPr>
+          <p:cNvPr id="2" name="TextBox 1"/>
+          <p:cNvSpPr txBox="1"/>
+          <p:nvPr/>
+        </p:nvSpPr>
+        <p:spPr>
+          <a:xfrm>
+            <a:off x="457200" y="228600"/>
+            <a:ext cx="10972800" cy="731520"/>
+          </a:xfrm>
+          <a:prstGeom prst="rect">
+            <a:avLst/>
+          </a:prstGeom>
+          <a:noFill/>
+        </p:spPr>
+        <p:txBody>
+          <a:bodyPr wrap="none">
+            <a:spAutoFit/>
+          </a:bodyPr>
+          <a:lstStyle/>
+          <a:p>
+            <a:pPr>
+              <a:defRPr sz="2800" b="1">
+                <a:solidFill>
+                  <a:srgbClr val="000000"/>
+                </a:solidFill>
+              </a:defRPr>
+            </a:pPr>
+            <a:r>
+              <a:t>Your Personal Dashboard</a:t>
+              <a:rPr>
+                <a:solidFill>
+                  <a:srgbClr val="000000"/>
+                </a:solidFill>
+              </a:rPr>
+            </a:r>
+          </a:p>
+        </p:txBody>
+      </p:sp>
+      <p:sp>
+        <p:nvSpPr>
+          <p:cNvPr id="3" name="TextBox 2"/>
+          <p:cNvSpPr txBox="1"/>
+          <p:nvPr/>
+        </p:nvSpPr>
+        <p:spPr>
+          <a:xfrm>
+            <a:off x="457200" y="1005840"/>
+            <a:ext cx="10972800" cy="5303520"/>
+          </a:xfrm>
+          <a:prstGeom prst="rect">
+            <a:avLst/>
+          </a:prstGeom>
+          <a:noFill/>
+        </p:spPr>
+        <p:txBody>
+          <a:bodyPr wrap="square">
+            <a:spAutoFit/>
+          </a:bodyPr>
+          <a:lstStyle/>
+          <a:p>
+            <a:pPr>
+              <a:spcAft>
+                <a:spcPts val="1000"/>
+              </a:spcAft>
+              <a:defRPr sz="1600">
+                <a:solidFill>
+                  <a:srgbClr val="000000"/>
+                </a:solidFill>
+              </a:defRPr>
+            </a:pPr>
+            <a:r>
+              <a:rPr>
+                <a:sz val="1600"/>
+                <a:solidFill>
+                  <a:srgbClr val="000000"/>
+                </a:solidFill>
+              </a:rPr>
+              <a:t>• Dashboard shows goal readiness and next exercise daily.</a:t>
+            </a:r>
+          </a:p>
+          <a:p>
+            <a:pPr>
+              <a:spcAft>
+                <a:spcPts val="1000"/>
+              </a:spcAft>
+              <a:defRPr sz="1600">
+                <a:solidFill>
+                  <a:srgbClr val="000000"/>
+                </a:solidFill>
+              </a:defRPr>
+            </a:pPr>
+            <a:r>
+              <a:rPr>
+                <a:sz val="1600"/>
+                <a:solidFill>
+                  <a:srgbClr val="000000"/>
+                </a:solidFill>
+              </a:rPr>
+              <a:t>• Tracks how many workouts you complete each week.</a:t>
+            </a:r>
+          </a:p>
+          <a:p>
+            <a:pPr>
+              <a:spcAft>
+                <a:spcPts val="1000"/>
+              </a:spcAft>
+              <a:defRPr sz="1600">
+                <a:solidFill>
+                  <a:srgbClr val="000000"/>
+                </a:solidFill>
+              </a:defRPr>
+            </a:pPr>
+            <a:r>
+              <a:rPr>
+                <a:sz val="1600"/>
+                <a:solidFill>
+                  <a:srgbClr val="000000"/>
+                </a:solidFill>
+              </a:rPr>
+              <a:t>• Shows your last ten finished exercises with dates.</a:t>
+            </a:r>
+          </a:p>
+          <a:p>
+            <a:pPr>
+              <a:spcAft>
+                <a:spcPts val="1000"/>
+              </a:spcAft>
+              <a:defRPr sz="1600">
+                <a:solidFill>
+                  <a:srgbClr val="000000"/>
+                </a:solidFill>
+              </a:defRPr>
+            </a:pPr>
+            <a:r>
+              <a:rPr>
+                <a:sz val="1600"/>
+                <a:solidFill>
+                  <a:srgbClr val="000000"/>
+                </a:solidFill>
+              </a:rPr>
+              <a:t>• Gives personalized feedback based on your goal progress.</a:t>
+            </a:r>
+          </a:p>
+          <a:p>
+            <a:pPr>
+              <a:spcAft>
+                <a:spcPts val="1000"/>
+              </a:spcAft>
+              <a:defRPr sz="1600">
+                <a:solidFill>
+                  <a:srgbClr val="000000"/>
+                </a:solidFill>
+              </a:defRPr>
+            </a:pPr>
+            <a:r>
+              <a:rPr>
+                <a:sz val="1600"/>
+                <a:solidFill>
+                  <a:srgbClr val="000000"/>
+                </a:solidFill>
+              </a:rPr>
+              <a:t>• Displays total sessions, current streak, and longest streak.</a:t>
+            </a:r>
+          </a:p>
+          <a:p>
+            <a:pPr>
+              <a:spcAft>
+                <a:spcPts val="1000"/>
+              </a:spcAft>
+              <a:defRPr sz="1600">
+                <a:solidFill>
+                  <a:srgbClr val="000000"/>
+                </a:solidFill>
+              </a:defRPr>
+            </a:pPr>
+            <a:r>
+              <a:rPr>
+                <a:sz val="1600"/>
+                <a:solidFill>
+                  <a:srgbClr val="000000"/>
+                </a:solidFill>
+              </a:rPr>
+              <a:t>• Quick links to exercises, goals, diet, and social features.</a:t>
+            </a:r>
+          </a:p>
+        </p:txBody>
+      </p:sp>
+    </p:spTree>
+    <p:bg>
+      <p:bgPr>
+        <a:solidFill>
+          <a:srgbClr val="FFFFFF"/>
+        </a:solidFill>
+      </p:bgPr>
+    </p:bg>
+  </p:cSld>
+  <p:clrMapOvr>
+    <a:masterClrMapping/>
+  </p:clrMapOvr>
+</p:sld>
+</file>
+
+<file path=ppt/slides/slide8.xml><?xml version="1.0" encoding="utf-8"?>
+<p:sld xmlns:a="http://schemas.openxmlformats.org/drawingml/2006/main" xmlns:p="http://schemas.openxmlformats.org/presentationml/2006/main" xmlns:r="http://schemas.openxmlformats.org/officeDocument/2006/relationships">
+  <p:cSld>
+    <p:spTree>
+      <p:nvGrpSpPr>
+        <p:cNvPr id="1" name=""/>
+        <p:cNvGrpSpPr/>
+        <p:nvPr/>
+      </p:nvGrpSpPr>
+      <p:grpSpPr/>
+      <p:sp>
+        <p:nvSpPr>
+          <p:cNvPr id="2" name="TextBox 1"/>
+          <p:cNvSpPr txBox="1"/>
+          <p:nvPr/>
+        </p:nvSpPr>
+        <p:spPr>
+          <a:xfrm>
+            <a:off x="457200" y="228600"/>
+            <a:ext cx="10972800" cy="731520"/>
+          </a:xfrm>
+          <a:prstGeom prst="rect">
+            <a:avLst/>
+          </a:prstGeom>
+          <a:noFill/>
+        </p:spPr>
+        <p:txBody>
+          <a:bodyPr wrap="none">
+            <a:spAutoFit/>
+          </a:bodyPr>
+          <a:lstStyle/>
+          <a:p>
+            <a:pPr>
+              <a:defRPr sz="2800" b="1">
+                <a:solidFill>
+                  <a:srgbClr val="000000"/>
+                </a:solidFill>
+              </a:defRPr>
+            </a:pPr>
+            <a:r>
+              <a:t>Workout Library</a:t>
+              <a:rPr>
+                <a:solidFill>
+                  <a:srgbClr val="000000"/>
+                </a:solidFill>
+              </a:rPr>
+            </a:r>
+          </a:p>
+        </p:txBody>
+      </p:sp>
+      <p:sp>
+        <p:nvSpPr>
+          <p:cNvPr id="3" name="TextBox 2"/>
+          <p:cNvSpPr txBox="1"/>
+          <p:nvPr/>
+        </p:nvSpPr>
+        <p:spPr>
+          <a:xfrm>
+            <a:off x="457200" y="1005840"/>
+            <a:ext cx="10972800" cy="5303520"/>
+          </a:xfrm>
+          <a:prstGeom prst="rect">
+            <a:avLst/>
+          </a:prstGeom>
+          <a:noFill/>
+        </p:spPr>
+        <p:txBody>
+          <a:bodyPr wrap="square">
+            <a:spAutoFit/>
+          </a:bodyPr>
+          <a:lstStyle/>
+          <a:p>
+            <a:pPr>
+              <a:spcAft>
+                <a:spcPts val="1000"/>
+              </a:spcAft>
+              <a:defRPr sz="1600">
+                <a:solidFill>
+                  <a:srgbClr val="000000"/>
+                </a:solidFill>
+              </a:defRPr>
+            </a:pPr>
+            <a:r>
+              <a:rPr>
+                <a:sz val="1600"/>
+                <a:solidFill>
+                  <a:srgbClr val="000000"/>
+                </a:solidFill>
+              </a:rPr>
+              <a:t>• Library has 36 exercises across 7 muscle group categories.</a:t>
+            </a:r>
+          </a:p>
+          <a:p>
+            <a:pPr>
+              <a:spcAft>
+                <a:spcPts val="1000"/>
+              </a:spcAft>
+              <a:defRPr sz="1600">
+                <a:solidFill>
+                  <a:srgbClr val="000000"/>
+                </a:solidFill>
+              </a:defRPr>
+            </a:pPr>
+            <a:r>
+              <a:rPr>
+                <a:sz val="1600"/>
+                <a:solidFill>
+                  <a:srgbClr val="000000"/>
+                </a:solidFill>
+              </a:rPr>
+              <a:t>• Categories: chest, back, shoulders, arms, legs, core, cardio.</a:t>
+            </a:r>
+          </a:p>
+          <a:p>
+            <a:pPr>
+              <a:spcAft>
+                <a:spcPts val="1000"/>
+              </a:spcAft>
+              <a:defRPr sz="1600">
+                <a:solidFill>
+                  <a:srgbClr val="000000"/>
+                </a:solidFill>
+              </a:defRPr>
+            </a:pPr>
+            <a:r>
+              <a:rPr>
+                <a:sz val="1600"/>
+                <a:solidFill>
+                  <a:srgbClr val="000000"/>
+                </a:solidFill>
+              </a:rPr>
+              <a:t>• Each exercise includes steps, form tips, and safety notes.</a:t>
+            </a:r>
+          </a:p>
+          <a:p>
+            <a:pPr>
+              <a:spcAft>
+                <a:spcPts val="1000"/>
+              </a:spcAft>
+              <a:defRPr sz="1600">
+                <a:solidFill>
+                  <a:srgbClr val="000000"/>
+                </a:solidFill>
+              </a:defRPr>
+            </a:pPr>
+            <a:r>
+              <a:rPr>
+                <a:sz val="1600"/>
+                <a:solidFill>
+                  <a:srgbClr val="000000"/>
+                </a:solidFill>
+              </a:rPr>
+              <a:t>• Filter exercises by goal type, difficulty, and equipment.</a:t>
+            </a:r>
+          </a:p>
+          <a:p>
+            <a:pPr>
+              <a:spcAft>
+                <a:spcPts val="1000"/>
+              </a:spcAft>
+              <a:defRPr sz="1600">
+                <a:solidFill>
+                  <a:srgbClr val="000000"/>
+                </a:solidFill>
+              </a:defRPr>
+            </a:pPr>
+            <a:r>
+              <a:rPr>
+                <a:sz val="1600"/>
+                <a:solidFill>
+                  <a:srgbClr val="000000"/>
+                </a:solidFill>
+              </a:rPr>
+              <a:t>• Detail page shows reps, sets, duration, and calories burned.</a:t>
+            </a:r>
+          </a:p>
+          <a:p>
+            <a:pPr>
+              <a:spcAft>
+                <a:spcPts val="1000"/>
+              </a:spcAft>
+              <a:defRPr sz="1600">
+                <a:solidFill>
+                  <a:srgbClr val="000000"/>
+                </a:solidFill>
+              </a:defRPr>
+            </a:pPr>
+            <a:r>
+              <a:rPr>
+                <a:sz val="1600"/>
+                <a:solidFill>
+                  <a:srgbClr val="000000"/>
+                </a:solidFill>
+              </a:rPr>
+              <a:t>• Home page features recommended workouts for quick access.</a:t>
+            </a:r>
+          </a:p>
+        </p:txBody>
+      </p:sp>
+    </p:spTree>
+    <p:bg>
+      <p:bgPr>
+        <a:solidFill>
+          <a:srgbClr val="FFFFFF"/>
+        </a:solidFill>
+      </p:bgPr>
+    </p:bg>
+  </p:cSld>
+  <p:clrMapOvr>
+    <a:masterClrMapping/>
+  </p:clrMapOvr>
+</p:sld>
+</file>
+
+<file path=ppt/slides/slide9.xml><?xml version="1.0" encoding="utf-8"?>
+<p:sld xmlns:a="http://schemas.openxmlformats.org/drawingml/2006/main" xmlns:p="http://schemas.openxmlformats.org/presentationml/2006/main" xmlns:r="http://schemas.openxmlformats.org/officeDocument/2006/relationships">
+  <p:cSld>
+    <p:spTree>
+      <p:nvGrpSpPr>
+        <p:cNvPr id="1" name=""/>
+        <p:cNvGrpSpPr/>
+        <p:nvPr/>
+      </p:nvGrpSpPr>
+      <p:grpSpPr/>
+      <p:sp>
+        <p:nvSpPr>
+          <p:cNvPr id="2" name="TextBox 1"/>
+          <p:cNvSpPr txBox="1"/>
+          <p:nvPr/>
+        </p:nvSpPr>
+        <p:spPr>
+          <a:xfrm>
+            <a:off x="457200" y="228600"/>
+            <a:ext cx="10972800" cy="731520"/>
+          </a:xfrm>
+          <a:prstGeom prst="rect">
+            <a:avLst/>
+          </a:prstGeom>
+          <a:noFill/>
+        </p:spPr>
+        <p:txBody>
+          <a:bodyPr wrap="none">
+            <a:spAutoFit/>
+          </a:bodyPr>
+          <a:lstStyle/>
+          <a:p>
+            <a:pPr>
+              <a:defRPr sz="2800" b="1">
+                <a:solidFill>
+                  <a:srgbClr val="000000"/>
+                </a:solidFill>
+              </a:defRPr>
+            </a:pPr>
+            <a:r>
+              <a:t>Setting and Tracking Goals</a:t>
+              <a:rPr>
+                <a:solidFill>
+                  <a:srgbClr val="000000"/>
+                </a:solidFill>
+              </a:rPr>
+            </a:r>
+          </a:p>
+        </p:txBody>
+      </p:sp>
+      <p:sp>
+        <p:nvSpPr>
+          <p:cNvPr id="3" name="TextBox 2"/>
+          <p:cNvSpPr txBox="1"/>
+          <p:nvPr/>
+        </p:nvSpPr>
+        <p:spPr>
+          <a:xfrm>
+            <a:off x="457200" y="1005840"/>
+            <a:ext cx="10972800" cy="5303520"/>
+          </a:xfrm>
+          <a:prstGeom prst="rect">
+            <a:avLst/>
+          </a:prstGeom>
+          <a:noFill/>
+        </p:spPr>
+        <p:txBody>
+          <a:bodyPr wrap="square">
+            <a:spAutoFit/>
+          </a:bodyPr>
+          <a:lstStyle/>
+          <a:p>
+            <a:pPr>
+              <a:spcAft>
+                <a:spcPts val="1000"/>
+              </a:spcAft>
+              <a:defRPr sz="1600">
+                <a:solidFill>
+                  <a:srgbClr val="000000"/>
+                </a:solidFill>
+              </a:defRPr>
+            </a:pPr>
+            <a:r>
+              <a:rPr>
+                <a:sz val="1600"/>
+                <a:solidFill>
+                  <a:srgbClr val="000000"/>
+                </a:solidFill>
+              </a:rPr>
+              <a:t>• Users create goals with type, target, timeline, and notes.</a:t>
+            </a:r>
+          </a:p>
+          <a:p>
+            <a:pPr>
+              <a:spcAft>
+                <a:spcPts val="1000"/>
+              </a:spcAft>
+              <a:defRPr sz="1600">
+                <a:solidFill>
+                  <a:srgbClr val="000000"/>
+                </a:solidFill>
+              </a:defRPr>
+            </a:pPr>
+            <a:r>
+              <a:rPr>
+                <a:sz val="1600"/>
+                <a:solidFill>
+                  <a:srgbClr val="000000"/>
+                </a:solidFill>
+              </a:rPr>
+              <a:t>• Eight goal types from calisthenics to muscle gain.</a:t>
+            </a:r>
+          </a:p>
+          <a:p>
+            <a:pPr>
+              <a:spcAft>
+                <a:spcPts val="1000"/>
+              </a:spcAft>
+              <a:defRPr sz="1600">
+                <a:solidFill>
+                  <a:srgbClr val="000000"/>
+                </a:solidFill>
+              </a:defRPr>
+            </a:pPr>
+            <a:r>
+              <a:rPr>
+                <a:sz val="1600"/>
+                <a:solidFill>
+                  <a:srgbClr val="000000"/>
+                </a:solidFill>
+              </a:rPr>
+              <a:t>• Focus areas target upper body, lower body, or core.</a:t>
+            </a:r>
+          </a:p>
+          <a:p>
+            <a:pPr>
+              <a:spcAft>
+                <a:spcPts val="1000"/>
+              </a:spcAft>
+              <a:defRPr sz="1600">
+                <a:solidFill>
+                  <a:srgbClr val="000000"/>
+                </a:solidFill>
+              </a:defRPr>
+            </a:pPr>
+            <a:r>
+              <a:rPr>
+                <a:sz val="1600"/>
+                <a:solidFill>
+                  <a:srgbClr val="000000"/>
+                </a:solidFill>
+              </a:rPr>
+              <a:t>• System auto-assigns exercises based on your goal type.</a:t>
+            </a:r>
+          </a:p>
+          <a:p>
+            <a:pPr>
+              <a:spcAft>
+                <a:spcPts val="1000"/>
+              </a:spcAft>
+              <a:defRPr sz="1600">
+                <a:solidFill>
+                  <a:srgbClr val="000000"/>
+                </a:solidFill>
+              </a:defRPr>
+            </a:pPr>
+            <a:r>
+              <a:rPr>
+                <a:sz val="1600"/>
+                <a:solidFill>
+                  <a:srgbClr val="000000"/>
+                </a:solidFill>
+              </a:rPr>
+              <a:t>• Progress updates as you complete assigned exercises.</a:t>
+            </a:r>
+          </a:p>
+          <a:p>
+            <a:pPr>
+              <a:spcAft>
+                <a:spcPts val="1000"/>
+              </a:spcAft>
+              <a:defRPr sz="1600">
+                <a:solidFill>
+                  <a:srgbClr val="000000"/>
+                </a:solidFill>
+              </a:defRPr>
+            </a:pPr>
+            <a:r>
+              <a:rPr>
+                <a:sz val="1600"/>
+                <a:solidFill>
+                  <a:srgbClr val="000000"/>
+                </a:solidFill>
+              </a:rPr>
+              <a:t>• Goals sync with dashboard and progress tracking.</a:t>
             </a:r>
           </a:p>
         </p:txBody>

</xml_diff>

<commit_message>
fix tech slide: simulated checkout not stripe, keep groq as real
</commit_message>
<xml_diff>
--- a/FitnessHub.pptx
+++ b/FitnessHub.pptx
@@ -1423,7 +1423,7 @@
                   <a:srgbClr val="000000"/>
                 </a:solidFill>
               </a:rPr>
-              <a:t>Tech stack: Django 5.0 backend, SQLite database, Groq AI API for the chatbot, Stripe for payments, standard web frontend, and Git/GitHub for collaboration.</a:t>
+              <a:t>Tech stack: Django 5.0 backend, SQLite database, Groq AI API (Llama model) for the chatbot, simulated checkout, standard web frontend, and Git/GitHub for collaboration.</a:t>
             </a:r>
           </a:p>
         </p:txBody>
@@ -6790,28 +6790,28 @@
                   <a:srgbClr val="000000"/>
                 </a:solidFill>
               </a:rPr>
-              <a:t>• Groq API with Llama model provides AI fitness coach responses.</a:t>
-            </a:r>
-          </a:p>
-          <a:p>
-            <a:pPr>
-              <a:spcAft>
-                <a:spcPts val="1000"/>
-              </a:spcAft>
-              <a:defRPr sz="1600">
-                <a:solidFill>
-                  <a:srgbClr val="000000"/>
-                </a:solidFill>
-              </a:defRPr>
-            </a:pPr>
-            <a:r>
-              <a:rPr>
-                <a:sz val="1600"/>
-                <a:solidFill>
-                  <a:srgbClr val="000000"/>
-                </a:solidFill>
-              </a:rPr>
-              <a:t>• Stripe API handles secure payment processing in the store.</a:t>
+              <a:t>• Groq API (Llama model) powers the AI fitness chatbot.</a:t>
+            </a:r>
+          </a:p>
+          <a:p>
+            <a:pPr>
+              <a:spcAft>
+                <a:spcPts val="1000"/>
+              </a:spcAft>
+              <a:defRPr sz="1600">
+                <a:solidFill>
+                  <a:srgbClr val="000000"/>
+                </a:solidFill>
+              </a:defRPr>
+            </a:pPr>
+            <a:r>
+              <a:rPr>
+                <a:sz val="1600"/>
+                <a:solidFill>
+                  <a:srgbClr val="000000"/>
+                </a:solidFill>
+              </a:rPr>
+              <a:t>• Simulated checkout handles store purchases without real payments.</a:t>
             </a:r>
           </a:p>
           <a:p>

</xml_diff>

<commit_message>
fix all slides with real project data: accurate numbers, USD pricing, actual focus areas, no password reset, real badge counts
</commit_message>
<xml_diff>
--- a/FitnessHub.pptx
+++ b/FitnessHub.pptx
@@ -598,7 +598,7 @@
                   <a:srgbClr val="000000"/>
                 </a:solidFill>
               </a:rPr>
-              <a:t>Authentication uses Django's built-in system. Registration creates a Profile automatically. The login page shows motivational quotes.</a:t>
+              <a:t>Authentication uses Django's built-in system. Registration auto-creates a Profile. No password reset is implemented yet.</a:t>
             </a:r>
           </a:p>
         </p:txBody>
@@ -823,7 +823,7 @@
                   <a:srgbClr val="000000"/>
                 </a:solidFill>
               </a:rPr>
-              <a:t>Users can set 8 goal types with 6 focus areas. The system assigns relevant exercises and tracks progress over time.</a:t>
+              <a:t>Users can set 8 goal types with 6 focus areas (upper body, lower body, core, pull, push, mobility). The system assigns relevant exercises.</a:t>
             </a:r>
           </a:p>
         </p:txBody>
@@ -1048,7 +1048,7 @@
                   <a:srgbClr val="000000"/>
                 </a:solidFill>
               </a:rPr>
-              <a:t>The store has 12 products across 3 categories with cart, checkout, atomic stock deduction, and order history.</a:t>
+              <a:t>The store has 12 products across 3 categories with cart, checkout, atomic stock deduction, and order history. Prices are in USD.</a:t>
             </a:r>
           </a:p>
         </p:txBody>
@@ -1273,7 +1273,7 @@
                   <a:srgbClr val="000000"/>
                 </a:solidFill>
               </a:rPr>
-              <a:t>The achievements system has 6 categories with unlockable badges. Each achievement has a threshold to reach.</a:t>
+              <a:t>16 badges across 3 categories: workout count (5), streak (6), volume (5). The model supports 6 categories but seed data uses 3.</a:t>
             </a:r>
           </a:p>
         </p:txBody>
@@ -5569,7 +5569,7 @@
                   <a:srgbClr val="000000"/>
                 </a:solidFill>
               </a:rPr>
-              <a:t>• Free shipping on orders over five thousand rupees.</a:t>
+              <a:t>• Free shipping on orders over $50.00.</a:t>
             </a:r>
           </a:p>
         </p:txBody>
@@ -6127,28 +6127,70 @@
                   <a:srgbClr val="000000"/>
                 </a:solidFill>
               </a:rPr>
-              <a:t>• Six achievement categories to unlock and collect.</a:t>
-            </a:r>
-          </a:p>
-          <a:p>
-            <a:pPr>
-              <a:spcAft>
-                <a:spcPts val="1000"/>
-              </a:spcAft>
-              <a:defRPr sz="1600">
-                <a:solidFill>
-                  <a:srgbClr val="000000"/>
-                </a:solidFill>
-              </a:defRPr>
-            </a:pPr>
-            <a:r>
-              <a:rPr>
-                <a:sz val="1600"/>
-                <a:solidFill>
-                  <a:srgbClr val="000000"/>
-                </a:solidFill>
-              </a:rPr>
-              <a:t>• Badges track workout count, streaks, and volume.</a:t>
+              <a:t>• 16 badges across workout count, streak, and volume.</a:t>
+            </a:r>
+          </a:p>
+          <a:p>
+            <a:pPr>
+              <a:spcAft>
+                <a:spcPts val="1000"/>
+              </a:spcAft>
+              <a:defRPr sz="1600">
+                <a:solidFill>
+                  <a:srgbClr val="000000"/>
+                </a:solidFill>
+              </a:defRPr>
+            </a:pPr>
+            <a:r>
+              <a:rPr>
+                <a:sz val="1600"/>
+                <a:solidFill>
+                  <a:srgbClr val="000000"/>
+                </a:solidFill>
+              </a:rPr>
+              <a:t>• 5 badges for hitting workout milestones like 100 sessions.</a:t>
+            </a:r>
+          </a:p>
+          <a:p>
+            <a:pPr>
+              <a:spcAft>
+                <a:spcPts val="1000"/>
+              </a:spcAft>
+              <a:defRPr sz="1600">
+                <a:solidFill>
+                  <a:srgbClr val="000000"/>
+                </a:solidFill>
+              </a:defRPr>
+            </a:pPr>
+            <a:r>
+              <a:rPr>
+                <a:sz val="1600"/>
+                <a:solidFill>
+                  <a:srgbClr val="000000"/>
+                </a:solidFill>
+              </a:rPr>
+              <a:t>• 6 badges for maintaining streaks up to 90 days.</a:t>
+            </a:r>
+          </a:p>
+          <a:p>
+            <a:pPr>
+              <a:spcAft>
+                <a:spcPts val="1000"/>
+              </a:spcAft>
+              <a:defRPr sz="1600">
+                <a:solidFill>
+                  <a:srgbClr val="000000"/>
+                </a:solidFill>
+              </a:defRPr>
+            </a:pPr>
+            <a:r>
+              <a:rPr>
+                <a:sz val="1600"/>
+                <a:solidFill>
+                  <a:srgbClr val="000000"/>
+                </a:solidFill>
+              </a:rPr>
+              <a:t>• 5 badges for reaching volume goals like 10,000 reps.</a:t>
             </a:r>
           </a:p>
           <a:p>
@@ -6170,48 +6212,6 @@
                 </a:solidFill>
               </a:rPr>
               <a:t>• Each badge can only be unlocked once.</a:t>
-            </a:r>
-          </a:p>
-          <a:p>
-            <a:pPr>
-              <a:spcAft>
-                <a:spcPts val="1000"/>
-              </a:spcAft>
-              <a:defRPr sz="1600">
-                <a:solidFill>
-                  <a:srgbClr val="000000"/>
-                </a:solidFill>
-              </a:defRPr>
-            </a:pPr>
-            <a:r>
-              <a:rPr>
-                <a:sz val="1600"/>
-                <a:solidFill>
-                  <a:srgbClr val="000000"/>
-                </a:solidFill>
-              </a:rPr>
-              <a:t>• Badges are color-coded: emerald, cyan, amber, and more.</a:t>
-            </a:r>
-          </a:p>
-          <a:p>
-            <a:pPr>
-              <a:spcAft>
-                <a:spcPts val="1000"/>
-              </a:spcAft>
-              <a:defRPr sz="1600">
-                <a:solidFill>
-                  <a:srgbClr val="000000"/>
-                </a:solidFill>
-              </a:defRPr>
-            </a:pPr>
-            <a:r>
-              <a:rPr>
-                <a:sz val="1600"/>
-                <a:solidFill>
-                  <a:srgbClr val="000000"/>
-                </a:solidFill>
-              </a:rPr>
-              <a:t>• Achievement page shows all badges and unlock status.</a:t>
             </a:r>
           </a:p>
         </p:txBody>
@@ -7688,28 +7688,28 @@
                   <a:srgbClr val="000000"/>
                 </a:solidFill>
               </a:rPr>
-              <a:t>• Password reset helps users recover forgotten accounts.</a:t>
-            </a:r>
-          </a:p>
-          <a:p>
-            <a:pPr>
-              <a:spcAft>
-                <a:spcPts val="1000"/>
-              </a:spcAft>
-              <a:defRPr sz="1600">
-                <a:solidFill>
-                  <a:srgbClr val="000000"/>
-                </a:solidFill>
-              </a:defRPr>
-            </a:pPr>
-            <a:r>
-              <a:rPr>
-                <a:sz val="1600"/>
-                <a:solidFill>
-                  <a:srgbClr val="000000"/>
-                </a:solidFill>
-              </a:rPr>
-              <a:t>• All authentication uses Django's built-in secure forms.</a:t>
+              <a:t>• Uses Django's built-in secure authentication system.</a:t>
+            </a:r>
+          </a:p>
+          <a:p>
+            <a:pPr>
+              <a:spcAft>
+                <a:spcPts val="1000"/>
+              </a:spcAft>
+              <a:defRPr sz="1600">
+                <a:solidFill>
+                  <a:srgbClr val="000000"/>
+                </a:solidFill>
+              </a:defRPr>
+            </a:pPr>
+            <a:r>
+              <a:rPr>
+                <a:sz val="1600"/>
+                <a:solidFill>
+                  <a:srgbClr val="000000"/>
+                </a:solidFill>
+              </a:rPr>
+              <a:t>• Profile stores age, height, weight, goal, and body type.</a:t>
             </a:r>
           </a:p>
         </p:txBody>
@@ -8288,7 +8288,7 @@
                   <a:srgbClr val="000000"/>
                 </a:solidFill>
               </a:rPr>
-              <a:t>• Focus areas target upper body, lower body, or core.</a:t>
+              <a:t>• Focus areas: upper body, lower body, core, pull, push.</a:t>
             </a:r>
           </a:p>
           <a:p>

</xml_diff>